<commit_message>
📊 update data 2026-03-31 07:55
</commit_message>
<xml_diff>
--- a/audit_approfondi_presentation.pptx
+++ b/audit_approfondi_presentation.pptx
@@ -4,6 +4,9 @@
   <p:sldMasterIdLst>
     <p:sldMasterId id="2147483648" r:id="rId1"/>
   </p:sldMasterIdLst>
+  <p:notesMasterIdLst>
+    <p:notesMasterId r:id="rId14"/>
+  </p:notesMasterIdLst>
   <p:sldIdLst>
     <p:sldId id="256" r:id="rId2"/>
     <p:sldId id="257" r:id="rId3"/>
@@ -18,10 +21,7 @@
     <p:sldId id="266" r:id="rId12"/>
     <p:sldId id="267" r:id="rId13"/>
   </p:sldIdLst>
-  <p:notesMasterIdLst>
-    <p:notesMasterId r:id="rId14"/>
-  </p:notesMasterIdLst>
-  <p:sldSz cx="9144000" cy="5143500"/>
+  <p:sldSz cx="9144000" cy="5143500" type="screen16x9"/>
   <p:notesSz cx="5143500" cy="9144000"/>
   <p:defaultTextStyle>
     <a:lvl1pPr marL="0" algn="l" defTabSz="914400" rtl="0" eaLnBrk="1" latinLnBrk="0" hangingPunct="1">
@@ -115,6 +115,11 @@
       </a:defRPr>
     </a:lvl9pPr>
   </p:defaultTextStyle>
+  <p:extLst>
+    <p:ext uri="{EFAFB233-063F-42B5-8137-9DF3F51BA10A}">
+      <p15:sldGuideLst xmlns:p15="http://schemas.microsoft.com/office/powerpoint/2012/main"/>
+    </p:ext>
+  </p:extLst>
 </p:presentation>
 </file>
 
@@ -140,234 +145,10 @@
           <a:chExt cx="0" cy="0"/>
         </a:xfrm>
       </p:grpSpPr>
-      <p:sp>
-        <p:nvSpPr>
-          <p:cNvPr id="2" name="Header Placeholder 1"/>
-          <p:cNvSpPr>
-            <a:spLocks noGrp="1"/>
-          </p:cNvSpPr>
-          <p:nvPr>
-            <p:ph type="hdr" sz="quarter"/>
-          </p:nvPr>
-        </p:nvSpPr>
-        <p:spPr>
-          <a:xfrm>
-            <a:off x="0" y="0"/>
-            <a:ext cx="2971800" cy="458788"/>
-          </a:xfrm>
-          <a:prstGeom prst="rect">
-            <a:avLst/>
-          </a:prstGeom>
-        </p:spPr>
-        <p:txBody>
-          <a:bodyPr vert="horz" lIns="91440" tIns="45720" rIns="91440" bIns="45720" rtlCol="0"/>
-          <a:lstStyle>
-            <a:lvl1pPr algn="l">
-              <a:defRPr sz="1200"/>
-            </a:lvl1pPr>
-          </a:lstStyle>
-          <a:p>
-            <a:endParaRPr lang="en-US"/>
-          </a:p>
-        </p:txBody>
-      </p:sp>
-      <p:sp>
-        <p:nvSpPr>
-          <p:cNvPr id="3" name="Date Placeholder 2"/>
-          <p:cNvSpPr>
-            <a:spLocks noGrp="1"/>
-          </p:cNvSpPr>
-          <p:nvPr>
-            <p:ph type="dt" idx="1"/>
-          </p:nvPr>
-        </p:nvSpPr>
-        <p:spPr>
-          <a:xfrm>
-            <a:off x="3884613" y="0"/>
-            <a:ext cx="2971800" cy="458788"/>
-          </a:xfrm>
-          <a:prstGeom prst="rect">
-            <a:avLst/>
-          </a:prstGeom>
-        </p:spPr>
-        <p:txBody>
-          <a:bodyPr vert="horz" lIns="91440" tIns="45720" rIns="91440" bIns="45720" rtlCol="0"/>
-          <a:lstStyle>
-            <a:lvl1pPr algn="r">
-              <a:defRPr sz="1200"/>
-            </a:lvl1pPr>
-          </a:lstStyle>
-          <a:p>
-            <a:fld id="{5282F153-3F37-0F45-9E97-73ACFA13230C}" type="datetimeFigureOut">
-              <a:rPr lang="en-US"/>
-              <a:t>7/23/19</a:t>
-            </a:fld>
-            <a:endParaRPr lang="en-US"/>
-          </a:p>
-        </p:txBody>
-      </p:sp>
-      <p:sp>
-        <p:nvSpPr>
-          <p:cNvPr id="4" name="Slide Image Placeholder 3"/>
-          <p:cNvSpPr>
-            <a:spLocks noGrp="1" noRot="1" noChangeAspect="1"/>
-          </p:cNvSpPr>
-          <p:nvPr>
-            <p:ph type="sldImg" idx="2"/>
-          </p:nvPr>
-        </p:nvSpPr>
-        <p:spPr>
-          <a:xfrm>
-            <a:off x="685800" y="1143000"/>
-            <a:ext cx="5486400" cy="3086100"/>
-          </a:xfrm>
-          <a:prstGeom prst="rect">
-            <a:avLst/>
-          </a:prstGeom>
-          <a:noFill/>
-          <a:ln w="12700">
-            <a:solidFill>
-              <a:prstClr val="black"/>
-            </a:solidFill>
-          </a:ln>
-        </p:spPr>
-        <p:txBody>
-          <a:bodyPr vert="horz" lIns="91440" tIns="45720" rIns="91440" bIns="45720" rtlCol="0" anchor="ctr"/>
-          <a:lstStyle/>
-          <a:p>
-            <a:endParaRPr lang="en-US"/>
-          </a:p>
-        </p:txBody>
-      </p:sp>
-      <p:sp>
-        <p:nvSpPr>
-          <p:cNvPr id="5" name="Notes Placeholder 4"/>
-          <p:cNvSpPr>
-            <a:spLocks noGrp="1"/>
-          </p:cNvSpPr>
-          <p:nvPr>
-            <p:ph type="body" sz="quarter" idx="3"/>
-          </p:nvPr>
-        </p:nvSpPr>
-        <p:spPr>
-          <a:xfrm>
-            <a:off x="685800" y="4400550"/>
-            <a:ext cx="5486400" cy="3600450"/>
-          </a:xfrm>
-          <a:prstGeom prst="rect">
-            <a:avLst/>
-          </a:prstGeom>
-        </p:spPr>
-        <p:txBody>
-          <a:bodyPr vert="horz" lIns="91440" tIns="45720" rIns="91440" bIns="45720" rtlCol="0"/>
-          <a:lstStyle/>
-          <a:p>
-            <a:pPr lvl="0"/>
-            <a:r>
-              <a:rPr lang="en-US"/>
-              <a:t>Click to edit Master text styles</a:t>
-            </a:r>
-          </a:p>
-          <a:p>
-            <a:pPr lvl="1"/>
-            <a:r>
-              <a:rPr lang="en-US"/>
-              <a:t>Second level</a:t>
-            </a:r>
-          </a:p>
-          <a:p>
-            <a:pPr lvl="2"/>
-            <a:r>
-              <a:rPr lang="en-US"/>
-              <a:t>Third level</a:t>
-            </a:r>
-          </a:p>
-          <a:p>
-            <a:pPr lvl="3"/>
-            <a:r>
-              <a:rPr lang="en-US"/>
-              <a:t>Fourth level</a:t>
-            </a:r>
-          </a:p>
-          <a:p>
-            <a:pPr lvl="4"/>
-            <a:r>
-              <a:rPr lang="en-US"/>
-              <a:t>Fifth level</a:t>
-            </a:r>
-          </a:p>
-        </p:txBody>
-      </p:sp>
-      <p:sp>
-        <p:nvSpPr>
-          <p:cNvPr id="6" name="Footer Placeholder 5"/>
-          <p:cNvSpPr>
-            <a:spLocks noGrp="1"/>
-          </p:cNvSpPr>
-          <p:nvPr>
-            <p:ph type="ftr" sz="quarter" idx="4"/>
-          </p:nvPr>
-        </p:nvSpPr>
-        <p:spPr>
-          <a:xfrm>
-            <a:off x="0" y="8685213"/>
-            <a:ext cx="2971800" cy="458787"/>
-          </a:xfrm>
-          <a:prstGeom prst="rect">
-            <a:avLst/>
-          </a:prstGeom>
-        </p:spPr>
-        <p:txBody>
-          <a:bodyPr vert="horz" lIns="91440" tIns="45720" rIns="91440" bIns="45720" rtlCol="0" anchor="b"/>
-          <a:lstStyle>
-            <a:lvl1pPr algn="l">
-              <a:defRPr sz="1200"/>
-            </a:lvl1pPr>
-          </a:lstStyle>
-          <a:p>
-            <a:endParaRPr lang="en-US"/>
-          </a:p>
-        </p:txBody>
-      </p:sp>
-      <p:sp>
-        <p:nvSpPr>
-          <p:cNvPr id="7" name="Slide Number Placeholder 6"/>
-          <p:cNvSpPr>
-            <a:spLocks noGrp="1"/>
-          </p:cNvSpPr>
-          <p:nvPr>
-            <p:ph type="sldNum" sz="quarter" idx="5"/>
-          </p:nvPr>
-        </p:nvSpPr>
-        <p:spPr>
-          <a:xfrm>
-            <a:off x="3884613" y="8685213"/>
-            <a:ext cx="2971800" cy="458787"/>
-          </a:xfrm>
-          <a:prstGeom prst="rect">
-            <a:avLst/>
-          </a:prstGeom>
-        </p:spPr>
-        <p:txBody>
-          <a:bodyPr vert="horz" lIns="91440" tIns="45720" rIns="91440" bIns="45720" rtlCol="0" anchor="b"/>
-          <a:lstStyle>
-            <a:lvl1pPr algn="r">
-              <a:defRPr sz="1200"/>
-            </a:lvl1pPr>
-          </a:lstStyle>
-          <a:p>
-            <a:fld id="{CE5E9CC1-C706-0F49-92D6-E571CC5EEA8F}" type="slidenum">
-              <a:rPr lang="en-US"/>
-              <a:t>‹#›</a:t>
-            </a:fld>
-            <a:endParaRPr lang="en-US"/>
-          </a:p>
-        </p:txBody>
-      </p:sp>
     </p:spTree>
     <p:extLst>
       <p:ext uri="{BB962C8B-B14F-4D97-AF65-F5344CB8AC3E}">
-        <p14:creationId xmlns:p14="http://schemas.microsoft.com/office/powerpoint/2010/main" val="1024086991"/>
+        <p14:creationId xmlns:p14="http://schemas.microsoft.com/office/powerpoint/2010/main" val="832046597"/>
       </p:ext>
     </p:extLst>
   </p:cSld>
@@ -511,10 +292,6 @@
           <a:bodyPr/>
           <a:lstStyle/>
           <a:p>
-            <a:r>
-              <a:rPr lang="en-US" dirty="0"/>
-              <a:t/>
-            </a:r>
             <a:endParaRPr lang="en-US" dirty="0"/>
           </a:p>
         </p:txBody>
@@ -599,10 +376,6 @@
           <a:bodyPr/>
           <a:lstStyle/>
           <a:p>
-            <a:r>
-              <a:rPr lang="en-US" dirty="0"/>
-              <a:t/>
-            </a:r>
             <a:endParaRPr lang="en-US" dirty="0"/>
           </a:p>
         </p:txBody>
@@ -687,10 +460,6 @@
           <a:bodyPr/>
           <a:lstStyle/>
           <a:p>
-            <a:r>
-              <a:rPr lang="en-US" dirty="0"/>
-              <a:t/>
-            </a:r>
             <a:endParaRPr lang="en-US" dirty="0"/>
           </a:p>
         </p:txBody>
@@ -775,10 +544,6 @@
           <a:bodyPr/>
           <a:lstStyle/>
           <a:p>
-            <a:r>
-              <a:rPr lang="en-US" dirty="0"/>
-              <a:t/>
-            </a:r>
             <a:endParaRPr lang="en-US" dirty="0"/>
           </a:p>
         </p:txBody>
@@ -863,10 +628,6 @@
           <a:bodyPr/>
           <a:lstStyle/>
           <a:p>
-            <a:r>
-              <a:rPr lang="en-US" dirty="0"/>
-              <a:t/>
-            </a:r>
             <a:endParaRPr lang="en-US" dirty="0"/>
           </a:p>
         </p:txBody>
@@ -951,10 +712,6 @@
           <a:bodyPr/>
           <a:lstStyle/>
           <a:p>
-            <a:r>
-              <a:rPr lang="en-US" dirty="0"/>
-              <a:t/>
-            </a:r>
             <a:endParaRPr lang="en-US" dirty="0"/>
           </a:p>
         </p:txBody>
@@ -1039,10 +796,6 @@
           <a:bodyPr/>
           <a:lstStyle/>
           <a:p>
-            <a:r>
-              <a:rPr lang="en-US" dirty="0"/>
-              <a:t/>
-            </a:r>
             <a:endParaRPr lang="en-US" dirty="0"/>
           </a:p>
         </p:txBody>
@@ -1127,10 +880,6 @@
           <a:bodyPr/>
           <a:lstStyle/>
           <a:p>
-            <a:r>
-              <a:rPr lang="en-US" dirty="0"/>
-              <a:t/>
-            </a:r>
             <a:endParaRPr lang="en-US" dirty="0"/>
           </a:p>
         </p:txBody>
@@ -1215,10 +964,6 @@
           <a:bodyPr/>
           <a:lstStyle/>
           <a:p>
-            <a:r>
-              <a:rPr lang="en-US" dirty="0"/>
-              <a:t/>
-            </a:r>
             <a:endParaRPr lang="en-US" dirty="0"/>
           </a:p>
         </p:txBody>
@@ -1303,10 +1048,6 @@
           <a:bodyPr/>
           <a:lstStyle/>
           <a:p>
-            <a:r>
-              <a:rPr lang="en-US" dirty="0"/>
-              <a:t/>
-            </a:r>
             <a:endParaRPr lang="en-US" dirty="0"/>
           </a:p>
         </p:txBody>
@@ -1391,10 +1132,6 @@
           <a:bodyPr/>
           <a:lstStyle/>
           <a:p>
-            <a:r>
-              <a:rPr lang="en-US" dirty="0"/>
-              <a:t/>
-            </a:r>
             <a:endParaRPr lang="en-US" dirty="0"/>
           </a:p>
         </p:txBody>
@@ -1479,10 +1216,6 @@
           <a:bodyPr/>
           <a:lstStyle/>
           <a:p>
-            <a:r>
-              <a:rPr lang="en-US" dirty="0"/>
-              <a:t/>
-            </a:r>
             <a:endParaRPr lang="en-US" dirty="0"/>
           </a:p>
         </p:txBody>
@@ -1556,6 +1289,11 @@
 <file path=ppt/slideMasters/slideMaster1.xml><?xml version="1.0" encoding="utf-8"?>
 <p:sldMaster xmlns:a="http://schemas.openxmlformats.org/drawingml/2006/main" xmlns:r="http://schemas.openxmlformats.org/officeDocument/2006/relationships" xmlns:p="http://schemas.openxmlformats.org/presentationml/2006/main">
   <p:cSld>
+    <p:bg>
+      <p:bgRef idx="1001">
+        <a:schemeClr val="bg1"/>
+      </p:bgRef>
+    </p:bg>
     <p:spTree>
       <p:nvGrpSpPr>
         <p:cNvPr id="1" name=""/>
@@ -1838,6 +1576,7 @@
         <a:solidFill>
           <a:srgbClr val="1A1A2E"/>
         </a:solidFill>
+        <a:effectLst/>
       </p:bgPr>
     </p:bg>
     <p:spTree>
@@ -1875,7 +1614,7 @@
           <a:bodyPr wrap="square" rtlCol="0" anchor="ctr"/>
           <a:lstStyle/>
           <a:p>
-            <a:pPr algn="ctr" indent="0" marL="0">
+            <a:pPr marL="0" indent="0" algn="ctr">
               <a:buNone/>
             </a:pPr>
             <a:r>
@@ -1901,7 +1640,7 @@
         </p:nvSpPr>
         <p:spPr>
           <a:xfrm>
-            <a:off x="457200" y="2560320"/>
+            <a:off x="457200" y="3025140"/>
             <a:ext cx="8229600" cy="731520"/>
           </a:xfrm>
           <a:prstGeom prst="rect">
@@ -1914,7 +1653,7 @@
           <a:bodyPr wrap="square" rtlCol="0" anchor="ctr"/>
           <a:lstStyle/>
           <a:p>
-            <a:pPr algn="ctr" indent="0" marL="0">
+            <a:pPr marL="0" indent="0" algn="ctr">
               <a:buNone/>
             </a:pPr>
             <a:r>
@@ -1953,7 +1692,7 @@
           <a:bodyPr wrap="square" rtlCol="0" anchor="ctr"/>
           <a:lstStyle/>
           <a:p>
-            <a:pPr algn="ctr" indent="0" marL="0">
+            <a:pPr marL="0" indent="0" algn="ctr">
               <a:buNone/>
             </a:pPr>
             <a:r>
@@ -1987,6 +1726,7 @@
         <a:solidFill>
           <a:srgbClr val="FFFFFF"/>
         </a:solidFill>
+        <a:effectLst/>
       </p:bgPr>
     </p:bg>
     <p:spTree>
@@ -2024,7 +1764,7 @@
           <a:bodyPr wrap="square" lIns="0" tIns="0" rIns="0" bIns="0" rtlCol="0" anchor="ctr"/>
           <a:lstStyle/>
           <a:p>
-            <a:pPr indent="0" marL="0">
+            <a:pPr marL="0" indent="0">
               <a:buNone/>
             </a:pPr>
             <a:r>
@@ -2066,7 +1806,7 @@
             <a:prstDash val="solid"/>
           </a:ln>
           <a:effectLst>
-            <a:outerShdw sx="100000" sy="100000" kx="0" ky="0" algn="bl" rotWithShape="0" blurRad="76200" dist="25400" dir="8100000">
+            <a:outerShdw blurRad="76200" dist="25400" dir="8100000" algn="bl" rotWithShape="0">
               <a:srgbClr val="000000">
                 <a:alpha val="12000"/>
               </a:srgbClr>
@@ -2115,7 +1855,7 @@
           <a:bodyPr wrap="square" lIns="0" tIns="0" rIns="0" bIns="0" rtlCol="0" anchor="ctr"/>
           <a:lstStyle/>
           <a:p>
-            <a:pPr algn="ctr" indent="0" marL="0">
+            <a:pPr marL="0" indent="0" algn="ctr">
               <a:buNone/>
             </a:pPr>
             <a:r>
@@ -2233,7 +1973,7 @@
             <a:prstDash val="solid"/>
           </a:ln>
           <a:effectLst>
-            <a:outerShdw sx="100000" sy="100000" kx="0" ky="0" algn="bl" rotWithShape="0" blurRad="76200" dist="25400" dir="8100000">
+            <a:outerShdw blurRad="76200" dist="25400" dir="8100000" algn="bl" rotWithShape="0">
               <a:srgbClr val="000000">
                 <a:alpha val="12000"/>
               </a:srgbClr>
@@ -2282,7 +2022,7 @@
           <a:bodyPr wrap="square" lIns="0" tIns="0" rIns="0" bIns="0" rtlCol="0" anchor="ctr"/>
           <a:lstStyle/>
           <a:p>
-            <a:pPr algn="ctr" indent="0" marL="0">
+            <a:pPr marL="0" indent="0" algn="ctr">
               <a:buNone/>
             </a:pPr>
             <a:r>
@@ -2400,7 +2140,7 @@
             <a:prstDash val="solid"/>
           </a:ln>
           <a:effectLst>
-            <a:outerShdw sx="100000" sy="100000" kx="0" ky="0" algn="bl" rotWithShape="0" blurRad="76200" dist="25400" dir="8100000">
+            <a:outerShdw blurRad="76200" dist="25400" dir="8100000" algn="bl" rotWithShape="0">
               <a:srgbClr val="000000">
                 <a:alpha val="12000"/>
               </a:srgbClr>
@@ -2449,7 +2189,7 @@
           <a:bodyPr wrap="square" lIns="0" tIns="0" rIns="0" bIns="0" rtlCol="0" anchor="ctr"/>
           <a:lstStyle/>
           <a:p>
-            <a:pPr algn="ctr" indent="0" marL="0">
+            <a:pPr marL="0" indent="0" algn="ctr">
               <a:buNone/>
             </a:pPr>
             <a:r>
@@ -2559,6 +2299,7 @@
         <a:solidFill>
           <a:srgbClr val="FFFFFF"/>
         </a:solidFill>
+        <a:effectLst/>
       </p:bgPr>
     </p:bg>
     <p:spTree>
@@ -2596,7 +2337,7 @@
           <a:bodyPr wrap="square" lIns="0" tIns="0" rIns="0" bIns="0" rtlCol="0" anchor="ctr"/>
           <a:lstStyle/>
           <a:p>
-            <a:pPr indent="0" marL="0">
+            <a:pPr marL="0" indent="0">
               <a:buNone/>
             </a:pPr>
             <a:r>
@@ -2660,7 +2401,7 @@
           <a:bodyPr wrap="square" lIns="0" tIns="0" rIns="0" bIns="0" rtlCol="0" anchor="ctr"/>
           <a:lstStyle/>
           <a:p>
-            <a:pPr algn="ctr" indent="0" marL="0">
+            <a:pPr marL="0" indent="0" algn="ctr">
               <a:buNone/>
             </a:pPr>
             <a:r>
@@ -2722,7 +2463,7 @@
           <a:bodyPr wrap="square" lIns="0" tIns="0" rIns="0" bIns="0" rtlCol="0" anchor="ctr"/>
           <a:lstStyle/>
           <a:p>
-            <a:pPr algn="ctr" indent="0" marL="0">
+            <a:pPr marL="0" indent="0" algn="ctr">
               <a:buNone/>
             </a:pPr>
             <a:r>
@@ -2761,7 +2502,7 @@
           <a:bodyPr wrap="square" lIns="0" tIns="0" rIns="0" bIns="0" rtlCol="0" anchor="ctr"/>
           <a:lstStyle/>
           <a:p>
-            <a:pPr algn="ctr" indent="0" marL="0">
+            <a:pPr marL="0" indent="0" algn="ctr">
               <a:buNone/>
             </a:pPr>
             <a:r>
@@ -2800,7 +2541,7 @@
           <a:bodyPr wrap="square" rtlCol="0" anchor="ctr"/>
           <a:lstStyle/>
           <a:p>
-            <a:pPr algn="ctr" indent="0" marL="0">
+            <a:pPr marL="0" indent="0" algn="ctr">
               <a:buNone/>
             </a:pPr>
             <a:r>
@@ -2817,7 +2558,7 @@
             <a:endParaRPr lang="en-US" sz="900" dirty="0"/>
           </a:p>
           <a:p>
-            <a:pPr algn="ctr" indent="0" marL="0">
+            <a:pPr marL="0" indent="0" algn="ctr">
               <a:buNone/>
             </a:pPr>
             <a:r>
@@ -2881,7 +2622,7 @@
           <a:bodyPr wrap="square" lIns="0" tIns="0" rIns="0" bIns="0" rtlCol="0" anchor="ctr"/>
           <a:lstStyle/>
           <a:p>
-            <a:pPr algn="ctr" indent="0" marL="0">
+            <a:pPr marL="0" indent="0" algn="ctr">
               <a:buNone/>
             </a:pPr>
             <a:r>
@@ -2943,7 +2684,7 @@
           <a:bodyPr wrap="square" lIns="0" tIns="0" rIns="0" bIns="0" rtlCol="0" anchor="ctr"/>
           <a:lstStyle/>
           <a:p>
-            <a:pPr algn="ctr" indent="0" marL="0">
+            <a:pPr marL="0" indent="0" algn="ctr">
               <a:buNone/>
             </a:pPr>
             <a:r>
@@ -2982,7 +2723,7 @@
           <a:bodyPr wrap="square" lIns="0" tIns="0" rIns="0" bIns="0" rtlCol="0" anchor="ctr"/>
           <a:lstStyle/>
           <a:p>
-            <a:pPr algn="ctr" indent="0" marL="0">
+            <a:pPr marL="0" indent="0" algn="ctr">
               <a:buNone/>
             </a:pPr>
             <a:r>
@@ -3021,7 +2762,7 @@
           <a:bodyPr wrap="square" rtlCol="0" anchor="ctr"/>
           <a:lstStyle/>
           <a:p>
-            <a:pPr algn="ctr" indent="0" marL="0">
+            <a:pPr marL="0" indent="0" algn="ctr">
               <a:buNone/>
             </a:pPr>
             <a:r>
@@ -3038,7 +2779,7 @@
             <a:endParaRPr lang="en-US" sz="900" dirty="0"/>
           </a:p>
           <a:p>
-            <a:pPr algn="ctr" indent="0" marL="0">
+            <a:pPr marL="0" indent="0" algn="ctr">
               <a:buNone/>
             </a:pPr>
             <a:r>
@@ -3102,7 +2843,7 @@
           <a:bodyPr wrap="square" lIns="0" tIns="0" rIns="0" bIns="0" rtlCol="0" anchor="ctr"/>
           <a:lstStyle/>
           <a:p>
-            <a:pPr algn="ctr" indent="0" marL="0">
+            <a:pPr marL="0" indent="0" algn="ctr">
               <a:buNone/>
             </a:pPr>
             <a:r>
@@ -3164,7 +2905,7 @@
           <a:bodyPr wrap="square" lIns="0" tIns="0" rIns="0" bIns="0" rtlCol="0" anchor="ctr"/>
           <a:lstStyle/>
           <a:p>
-            <a:pPr algn="ctr" indent="0" marL="0">
+            <a:pPr marL="0" indent="0" algn="ctr">
               <a:buNone/>
             </a:pPr>
             <a:r>
@@ -3203,7 +2944,7 @@
           <a:bodyPr wrap="square" lIns="0" tIns="0" rIns="0" bIns="0" rtlCol="0" anchor="ctr"/>
           <a:lstStyle/>
           <a:p>
-            <a:pPr algn="ctr" indent="0" marL="0">
+            <a:pPr marL="0" indent="0" algn="ctr">
               <a:buNone/>
             </a:pPr>
             <a:r>
@@ -3242,7 +2983,7 @@
           <a:bodyPr wrap="square" rtlCol="0" anchor="ctr"/>
           <a:lstStyle/>
           <a:p>
-            <a:pPr algn="ctr" indent="0" marL="0">
+            <a:pPr marL="0" indent="0" algn="ctr">
               <a:buNone/>
             </a:pPr>
             <a:r>
@@ -3259,7 +3000,7 @@
             <a:endParaRPr lang="en-US" sz="900" dirty="0"/>
           </a:p>
           <a:p>
-            <a:pPr algn="ctr" indent="0" marL="0">
+            <a:pPr marL="0" indent="0" algn="ctr">
               <a:buNone/>
             </a:pPr>
             <a:r>
@@ -3323,7 +3064,7 @@
           <a:bodyPr wrap="square" lIns="0" tIns="0" rIns="0" bIns="0" rtlCol="0" anchor="ctr"/>
           <a:lstStyle/>
           <a:p>
-            <a:pPr algn="ctr" indent="0" marL="0">
+            <a:pPr marL="0" indent="0" algn="ctr">
               <a:buNone/>
             </a:pPr>
             <a:r>
@@ -3385,7 +3126,7 @@
           <a:bodyPr wrap="square" lIns="0" tIns="0" rIns="0" bIns="0" rtlCol="0" anchor="ctr"/>
           <a:lstStyle/>
           <a:p>
-            <a:pPr algn="ctr" indent="0" marL="0">
+            <a:pPr marL="0" indent="0" algn="ctr">
               <a:buNone/>
             </a:pPr>
             <a:r>
@@ -3424,7 +3165,7 @@
           <a:bodyPr wrap="square" lIns="0" tIns="0" rIns="0" bIns="0" rtlCol="0" anchor="ctr"/>
           <a:lstStyle/>
           <a:p>
-            <a:pPr algn="ctr" indent="0" marL="0">
+            <a:pPr marL="0" indent="0" algn="ctr">
               <a:buNone/>
             </a:pPr>
             <a:r>
@@ -3463,7 +3204,7 @@
           <a:bodyPr wrap="square" rtlCol="0" anchor="ctr"/>
           <a:lstStyle/>
           <a:p>
-            <a:pPr algn="ctr" indent="0" marL="0">
+            <a:pPr marL="0" indent="0" algn="ctr">
               <a:buNone/>
             </a:pPr>
             <a:r>
@@ -3480,7 +3221,7 @@
             <a:endParaRPr lang="en-US" sz="900" dirty="0"/>
           </a:p>
           <a:p>
-            <a:pPr algn="ctr" indent="0" marL="0">
+            <a:pPr marL="0" indent="0" algn="ctr">
               <a:buNone/>
             </a:pPr>
             <a:r>
@@ -3544,7 +3285,7 @@
           <a:bodyPr wrap="square" lIns="0" tIns="0" rIns="0" bIns="0" rtlCol="0" anchor="ctr"/>
           <a:lstStyle/>
           <a:p>
-            <a:pPr algn="ctr" indent="0" marL="0">
+            <a:pPr marL="0" indent="0" algn="ctr">
               <a:buNone/>
             </a:pPr>
             <a:r>
@@ -3583,7 +3324,7 @@
           <a:bodyPr wrap="square" lIns="0" tIns="0" rIns="0" bIns="0" rtlCol="0" anchor="ctr"/>
           <a:lstStyle/>
           <a:p>
-            <a:pPr algn="ctr" indent="0" marL="0">
+            <a:pPr marL="0" indent="0" algn="ctr">
               <a:buNone/>
             </a:pPr>
             <a:r>
@@ -3622,7 +3363,7 @@
           <a:bodyPr wrap="square" lIns="0" tIns="0" rIns="0" bIns="0" rtlCol="0" anchor="ctr"/>
           <a:lstStyle/>
           <a:p>
-            <a:pPr algn="ctr" indent="0" marL="0">
+            <a:pPr marL="0" indent="0" algn="ctr">
               <a:buNone/>
             </a:pPr>
             <a:r>
@@ -3661,7 +3402,7 @@
           <a:bodyPr wrap="square" rtlCol="0" anchor="ctr"/>
           <a:lstStyle/>
           <a:p>
-            <a:pPr algn="ctr" indent="0" marL="0">
+            <a:pPr marL="0" indent="0" algn="ctr">
               <a:buNone/>
             </a:pPr>
             <a:r>
@@ -3678,7 +3419,7 @@
             <a:endParaRPr lang="en-US" sz="900" dirty="0"/>
           </a:p>
           <a:p>
-            <a:pPr algn="ctr" indent="0" marL="0">
+            <a:pPr marL="0" indent="0" algn="ctr">
               <a:buNone/>
             </a:pPr>
             <a:r>
@@ -3712,6 +3453,7 @@
         <a:solidFill>
           <a:srgbClr val="1A1A2E"/>
         </a:solidFill>
+        <a:effectLst/>
       </p:bgPr>
     </p:bg>
     <p:spTree>
@@ -3749,7 +3491,7 @@
           <a:bodyPr wrap="square" lIns="0" tIns="0" rIns="0" bIns="0" rtlCol="0" anchor="ctr"/>
           <a:lstStyle/>
           <a:p>
-            <a:pPr algn="ctr" indent="0" marL="0">
+            <a:pPr marL="0" indent="0" algn="ctr">
               <a:buNone/>
             </a:pPr>
             <a:r>
@@ -3788,7 +3530,7 @@
           <a:bodyPr wrap="square" rtlCol="0" anchor="ctr"/>
           <a:lstStyle/>
           <a:p>
-            <a:pPr algn="l" indent="0" marL="0">
+            <a:pPr marL="0" indent="0" algn="l">
               <a:buNone/>
             </a:pPr>
             <a:r>
@@ -3805,7 +3547,7 @@
             <a:endParaRPr lang="en-US" sz="1800" dirty="0"/>
           </a:p>
           <a:p>
-            <a:pPr algn="l" indent="0" marL="0">
+            <a:pPr marL="0" indent="0" algn="l">
               <a:buNone/>
             </a:pPr>
             <a:r>
@@ -3822,7 +3564,7 @@
             <a:endParaRPr lang="en-US" sz="1800" dirty="0"/>
           </a:p>
           <a:p>
-            <a:pPr algn="l" indent="0" marL="0">
+            <a:pPr marL="0" indent="0" algn="l">
               <a:buNone/>
             </a:pPr>
             <a:r>
@@ -3839,7 +3581,7 @@
             <a:endParaRPr lang="en-US" sz="1800" dirty="0"/>
           </a:p>
           <a:p>
-            <a:pPr algn="l" indent="0" marL="0">
+            <a:pPr marL="0" indent="0" algn="l">
               <a:buNone/>
             </a:pPr>
             <a:r>
@@ -3856,7 +3598,7 @@
             <a:endParaRPr lang="en-US" sz="1800" dirty="0"/>
           </a:p>
           <a:p>
-            <a:pPr algn="l" indent="0" marL="0">
+            <a:pPr marL="0" indent="0" algn="l">
               <a:buNone/>
             </a:pPr>
             <a:r>
@@ -3895,7 +3637,7 @@
           <a:bodyPr wrap="square" lIns="0" tIns="0" rIns="0" bIns="0" rtlCol="0" anchor="ctr"/>
           <a:lstStyle/>
           <a:p>
-            <a:pPr algn="ctr" indent="0" marL="0">
+            <a:pPr marL="0" indent="0" algn="ctr">
               <a:buNone/>
             </a:pPr>
             <a:r>
@@ -3929,6 +3671,7 @@
         <a:solidFill>
           <a:srgbClr val="FFFFFF"/>
         </a:solidFill>
+        <a:effectLst/>
       </p:bgPr>
     </p:bg>
     <p:spTree>
@@ -3966,7 +3709,7 @@
           <a:bodyPr wrap="square" lIns="0" tIns="0" rIns="0" bIns="0" rtlCol="0" anchor="ctr"/>
           <a:lstStyle/>
           <a:p>
-            <a:pPr indent="0" marL="0">
+            <a:pPr marL="0" indent="0">
               <a:buNone/>
             </a:pPr>
             <a:r>
@@ -4008,7 +3751,7 @@
             <a:prstDash val="solid"/>
           </a:ln>
           <a:effectLst>
-            <a:outerShdw sx="100000" sy="100000" kx="0" ky="0" algn="bl" rotWithShape="0" blurRad="76200" dist="25400" dir="8100000">
+            <a:outerShdw blurRad="76200" dist="25400" dir="8100000" algn="bl" rotWithShape="0">
               <a:srgbClr val="000000">
                 <a:alpha val="12000"/>
               </a:srgbClr>
@@ -4057,7 +3800,7 @@
           <a:bodyPr wrap="square" lIns="0" tIns="0" rIns="0" bIns="0" rtlCol="0" anchor="ctr"/>
           <a:lstStyle/>
           <a:p>
-            <a:pPr algn="ctr" indent="0" marL="0">
+            <a:pPr marL="0" indent="0" algn="ctr">
               <a:buNone/>
             </a:pPr>
             <a:r>
@@ -4096,7 +3839,7 @@
           <a:bodyPr wrap="square" lIns="0" tIns="0" rIns="0" bIns="0" rtlCol="0" anchor="ctr"/>
           <a:lstStyle/>
           <a:p>
-            <a:pPr algn="ctr" indent="0" marL="0">
+            <a:pPr marL="0" indent="0" algn="ctr">
               <a:buNone/>
             </a:pPr>
             <a:r>
@@ -4135,7 +3878,7 @@
           <a:bodyPr wrap="square" lIns="0" tIns="0" rIns="0" bIns="0" rtlCol="0" anchor="ctr"/>
           <a:lstStyle/>
           <a:p>
-            <a:pPr algn="ctr" indent="0" marL="0">
+            <a:pPr marL="0" indent="0" algn="ctr">
               <a:buNone/>
             </a:pPr>
             <a:r>
@@ -4177,7 +3920,7 @@
             <a:prstDash val="solid"/>
           </a:ln>
           <a:effectLst>
-            <a:outerShdw sx="100000" sy="100000" kx="0" ky="0" algn="bl" rotWithShape="0" blurRad="76200" dist="25400" dir="8100000">
+            <a:outerShdw blurRad="76200" dist="25400" dir="8100000" algn="bl" rotWithShape="0">
               <a:srgbClr val="000000">
                 <a:alpha val="12000"/>
               </a:srgbClr>
@@ -4226,7 +3969,7 @@
           <a:bodyPr wrap="square" lIns="0" tIns="0" rIns="0" bIns="0" rtlCol="0" anchor="ctr"/>
           <a:lstStyle/>
           <a:p>
-            <a:pPr algn="ctr" indent="0" marL="0">
+            <a:pPr marL="0" indent="0" algn="ctr">
               <a:buNone/>
             </a:pPr>
             <a:r>
@@ -4265,7 +4008,7 @@
           <a:bodyPr wrap="square" lIns="0" tIns="0" rIns="0" bIns="0" rtlCol="0" anchor="ctr"/>
           <a:lstStyle/>
           <a:p>
-            <a:pPr algn="ctr" indent="0" marL="0">
+            <a:pPr marL="0" indent="0" algn="ctr">
               <a:buNone/>
             </a:pPr>
             <a:r>
@@ -4304,7 +4047,7 @@
           <a:bodyPr wrap="square" lIns="0" tIns="0" rIns="0" bIns="0" rtlCol="0" anchor="ctr"/>
           <a:lstStyle/>
           <a:p>
-            <a:pPr algn="ctr" indent="0" marL="0">
+            <a:pPr marL="0" indent="0" algn="ctr">
               <a:buNone/>
             </a:pPr>
             <a:r>
@@ -4346,7 +4089,7 @@
             <a:prstDash val="solid"/>
           </a:ln>
           <a:effectLst>
-            <a:outerShdw sx="100000" sy="100000" kx="0" ky="0" algn="bl" rotWithShape="0" blurRad="76200" dist="25400" dir="8100000">
+            <a:outerShdw blurRad="76200" dist="25400" dir="8100000" algn="bl" rotWithShape="0">
               <a:srgbClr val="000000">
                 <a:alpha val="12000"/>
               </a:srgbClr>
@@ -4395,7 +4138,7 @@
           <a:bodyPr wrap="square" lIns="0" tIns="0" rIns="0" bIns="0" rtlCol="0" anchor="ctr"/>
           <a:lstStyle/>
           <a:p>
-            <a:pPr algn="ctr" indent="0" marL="0">
+            <a:pPr marL="0" indent="0" algn="ctr">
               <a:buNone/>
             </a:pPr>
             <a:r>
@@ -4434,7 +4177,7 @@
           <a:bodyPr wrap="square" lIns="0" tIns="0" rIns="0" bIns="0" rtlCol="0" anchor="ctr"/>
           <a:lstStyle/>
           <a:p>
-            <a:pPr algn="ctr" indent="0" marL="0">
+            <a:pPr marL="0" indent="0" algn="ctr">
               <a:buNone/>
             </a:pPr>
             <a:r>
@@ -4473,7 +4216,7 @@
           <a:bodyPr wrap="square" lIns="0" tIns="0" rIns="0" bIns="0" rtlCol="0" anchor="ctr"/>
           <a:lstStyle/>
           <a:p>
-            <a:pPr algn="ctr" indent="0" marL="0">
+            <a:pPr marL="0" indent="0" algn="ctr">
               <a:buNone/>
             </a:pPr>
             <a:r>
@@ -4515,7 +4258,7 @@
             <a:prstDash val="solid"/>
           </a:ln>
           <a:effectLst>
-            <a:outerShdw sx="100000" sy="100000" kx="0" ky="0" algn="bl" rotWithShape="0" blurRad="76200" dist="25400" dir="8100000">
+            <a:outerShdw blurRad="76200" dist="25400" dir="8100000" algn="bl" rotWithShape="0">
               <a:srgbClr val="000000">
                 <a:alpha val="12000"/>
               </a:srgbClr>
@@ -4564,7 +4307,7 @@
           <a:bodyPr wrap="square" lIns="0" tIns="0" rIns="0" bIns="0" rtlCol="0" anchor="ctr"/>
           <a:lstStyle/>
           <a:p>
-            <a:pPr algn="ctr" indent="0" marL="0">
+            <a:pPr marL="0" indent="0" algn="ctr">
               <a:buNone/>
             </a:pPr>
             <a:r>
@@ -4603,7 +4346,7 @@
           <a:bodyPr wrap="square" lIns="0" tIns="0" rIns="0" bIns="0" rtlCol="0" anchor="ctr"/>
           <a:lstStyle/>
           <a:p>
-            <a:pPr algn="ctr" indent="0" marL="0">
+            <a:pPr marL="0" indent="0" algn="ctr">
               <a:buNone/>
             </a:pPr>
             <a:r>
@@ -4642,7 +4385,7 @@
           <a:bodyPr wrap="square" lIns="0" tIns="0" rIns="0" bIns="0" rtlCol="0" anchor="ctr"/>
           <a:lstStyle/>
           <a:p>
-            <a:pPr algn="ctr" indent="0" marL="0">
+            <a:pPr marL="0" indent="0" algn="ctr">
               <a:buNone/>
             </a:pPr>
             <a:r>
@@ -4684,7 +4427,7 @@
             <a:prstDash val="solid"/>
           </a:ln>
           <a:effectLst>
-            <a:outerShdw sx="100000" sy="100000" kx="0" ky="0" algn="bl" rotWithShape="0" blurRad="76200" dist="25400" dir="8100000">
+            <a:outerShdw blurRad="76200" dist="25400" dir="8100000" algn="bl" rotWithShape="0">
               <a:srgbClr val="000000">
                 <a:alpha val="12000"/>
               </a:srgbClr>
@@ -4733,7 +4476,7 @@
           <a:bodyPr wrap="square" lIns="0" tIns="0" rIns="0" bIns="0" rtlCol="0" anchor="ctr"/>
           <a:lstStyle/>
           <a:p>
-            <a:pPr algn="ctr" indent="0" marL="0">
+            <a:pPr marL="0" indent="0" algn="ctr">
               <a:buNone/>
             </a:pPr>
             <a:r>
@@ -4772,7 +4515,7 @@
           <a:bodyPr wrap="square" lIns="0" tIns="0" rIns="0" bIns="0" rtlCol="0" anchor="ctr"/>
           <a:lstStyle/>
           <a:p>
-            <a:pPr algn="ctr" indent="0" marL="0">
+            <a:pPr marL="0" indent="0" algn="ctr">
               <a:buNone/>
             </a:pPr>
             <a:r>
@@ -4811,7 +4554,7 @@
           <a:bodyPr wrap="square" lIns="0" tIns="0" rIns="0" bIns="0" rtlCol="0" anchor="ctr"/>
           <a:lstStyle/>
           <a:p>
-            <a:pPr algn="ctr" indent="0" marL="0">
+            <a:pPr marL="0" indent="0" algn="ctr">
               <a:buNone/>
             </a:pPr>
             <a:r>
@@ -4853,7 +4596,7 @@
             <a:prstDash val="solid"/>
           </a:ln>
           <a:effectLst>
-            <a:outerShdw sx="100000" sy="100000" kx="0" ky="0" algn="bl" rotWithShape="0" blurRad="76200" dist="25400" dir="8100000">
+            <a:outerShdw blurRad="76200" dist="25400" dir="8100000" algn="bl" rotWithShape="0">
               <a:srgbClr val="000000">
                 <a:alpha val="12000"/>
               </a:srgbClr>
@@ -4902,7 +4645,7 @@
           <a:bodyPr wrap="square" lIns="0" tIns="0" rIns="0" bIns="0" rtlCol="0" anchor="ctr"/>
           <a:lstStyle/>
           <a:p>
-            <a:pPr algn="ctr" indent="0" marL="0">
+            <a:pPr marL="0" indent="0" algn="ctr">
               <a:buNone/>
             </a:pPr>
             <a:r>
@@ -4941,7 +4684,7 @@
           <a:bodyPr wrap="square" lIns="0" tIns="0" rIns="0" bIns="0" rtlCol="0" anchor="ctr"/>
           <a:lstStyle/>
           <a:p>
-            <a:pPr algn="ctr" indent="0" marL="0">
+            <a:pPr marL="0" indent="0" algn="ctr">
               <a:buNone/>
             </a:pPr>
             <a:r>
@@ -4980,7 +4723,7 @@
           <a:bodyPr wrap="square" lIns="0" tIns="0" rIns="0" bIns="0" rtlCol="0" anchor="ctr"/>
           <a:lstStyle/>
           <a:p>
-            <a:pPr algn="ctr" indent="0" marL="0">
+            <a:pPr marL="0" indent="0" algn="ctr">
               <a:buNone/>
             </a:pPr>
             <a:r>
@@ -5022,7 +4765,7 @@
             <a:prstDash val="solid"/>
           </a:ln>
           <a:effectLst>
-            <a:outerShdw sx="100000" sy="100000" kx="0" ky="0" algn="bl" rotWithShape="0" blurRad="76200" dist="25400" dir="8100000">
+            <a:outerShdw blurRad="76200" dist="25400" dir="8100000" algn="bl" rotWithShape="0">
               <a:srgbClr val="000000">
                 <a:alpha val="12000"/>
               </a:srgbClr>
@@ -5071,7 +4814,7 @@
           <a:bodyPr wrap="square" lIns="0" tIns="0" rIns="0" bIns="0" rtlCol="0" anchor="ctr"/>
           <a:lstStyle/>
           <a:p>
-            <a:pPr algn="ctr" indent="0" marL="0">
+            <a:pPr marL="0" indent="0" algn="ctr">
               <a:buNone/>
             </a:pPr>
             <a:r>
@@ -5110,7 +4853,7 @@
           <a:bodyPr wrap="square" lIns="0" tIns="0" rIns="0" bIns="0" rtlCol="0" anchor="ctr"/>
           <a:lstStyle/>
           <a:p>
-            <a:pPr algn="ctr" indent="0" marL="0">
+            <a:pPr marL="0" indent="0" algn="ctr">
               <a:buNone/>
             </a:pPr>
             <a:r>
@@ -5149,7 +4892,7 @@
           <a:bodyPr wrap="square" lIns="0" tIns="0" rIns="0" bIns="0" rtlCol="0" anchor="ctr"/>
           <a:lstStyle/>
           <a:p>
-            <a:pPr algn="ctr" indent="0" marL="0">
+            <a:pPr marL="0" indent="0" algn="ctr">
               <a:buNone/>
             </a:pPr>
             <a:r>
@@ -5191,7 +4934,7 @@
             <a:prstDash val="solid"/>
           </a:ln>
           <a:effectLst>
-            <a:outerShdw sx="100000" sy="100000" kx="0" ky="0" algn="bl" rotWithShape="0" blurRad="76200" dist="25400" dir="8100000">
+            <a:outerShdw blurRad="76200" dist="25400" dir="8100000" algn="bl" rotWithShape="0">
               <a:srgbClr val="000000">
                 <a:alpha val="12000"/>
               </a:srgbClr>
@@ -5240,7 +4983,7 @@
           <a:bodyPr wrap="square" lIns="0" tIns="0" rIns="0" bIns="0" rtlCol="0" anchor="ctr"/>
           <a:lstStyle/>
           <a:p>
-            <a:pPr algn="ctr" indent="0" marL="0">
+            <a:pPr marL="0" indent="0" algn="ctr">
               <a:buNone/>
             </a:pPr>
             <a:r>
@@ -5279,7 +5022,7 @@
           <a:bodyPr wrap="square" lIns="0" tIns="0" rIns="0" bIns="0" rtlCol="0" anchor="ctr"/>
           <a:lstStyle/>
           <a:p>
-            <a:pPr algn="ctr" indent="0" marL="0">
+            <a:pPr marL="0" indent="0" algn="ctr">
               <a:buNone/>
             </a:pPr>
             <a:r>
@@ -5318,7 +5061,7 @@
           <a:bodyPr wrap="square" lIns="0" tIns="0" rIns="0" bIns="0" rtlCol="0" anchor="ctr"/>
           <a:lstStyle/>
           <a:p>
-            <a:pPr algn="ctr" indent="0" marL="0">
+            <a:pPr marL="0" indent="0" algn="ctr">
               <a:buNone/>
             </a:pPr>
             <a:r>
@@ -5352,6 +5095,7 @@
         <a:solidFill>
           <a:srgbClr val="FFFFFF"/>
         </a:solidFill>
+        <a:effectLst/>
       </p:bgPr>
     </p:bg>
     <p:spTree>
@@ -5389,7 +5133,7 @@
           <a:bodyPr wrap="square" lIns="0" tIns="0" rIns="0" bIns="0" rtlCol="0" anchor="ctr"/>
           <a:lstStyle/>
           <a:p>
-            <a:pPr indent="0" marL="0">
+            <a:pPr marL="0" indent="0">
               <a:buNone/>
             </a:pPr>
             <a:r>
@@ -5423,16 +5167,34 @@
         </p:nvGraphicFramePr>
         <p:xfrm>
           <a:off x="1371600" y="1005840"/>
-          <a:ext cx="6400800" cy="3474720"/>
+          <a:ext cx="6400800" cy="3291840"/>
         </p:xfrm>
         <a:graphic>
           <a:graphicData uri="http://schemas.openxmlformats.org/drawingml/2006/table">
             <a:tbl>
               <a:tblPr/>
               <a:tblGrid>
-                <a:gridCol w="3840480"/>
-                <a:gridCol w="1097280"/>
-                <a:gridCol w="1463040"/>
+                <a:gridCol w="3840480">
+                  <a:extLst>
+                    <a:ext uri="{9D8B030D-6E8A-4147-A177-3AD203B41FA5}">
+                      <a16:colId xmlns:a16="http://schemas.microsoft.com/office/drawing/2014/main" val="20000"/>
+                    </a:ext>
+                  </a:extLst>
+                </a:gridCol>
+                <a:gridCol w="1097280">
+                  <a:extLst>
+                    <a:ext uri="{9D8B030D-6E8A-4147-A177-3AD203B41FA5}">
+                      <a16:colId xmlns:a16="http://schemas.microsoft.com/office/drawing/2014/main" val="20001"/>
+                    </a:ext>
+                  </a:extLst>
+                </a:gridCol>
+                <a:gridCol w="1463040">
+                  <a:extLst>
+                    <a:ext uri="{9D8B030D-6E8A-4147-A177-3AD203B41FA5}">
+                      <a16:colId xmlns:a16="http://schemas.microsoft.com/office/drawing/2014/main" val="20002"/>
+                    </a:ext>
+                  </a:extLst>
+                </a:gridCol>
               </a:tblGrid>
               <a:tr h="411480">
                 <a:tc>
@@ -5440,7 +5202,7 @@
                     <a:bodyPr/>
                     <a:lstStyle/>
                     <a:p>
-                      <a:pPr algn="l" indent="0" marL="0">
+                      <a:pPr marL="0" indent="0" algn="l">
                         <a:buNone/>
                       </a:pPr>
                       <a:r>
@@ -5454,7 +5216,7 @@
                       <a:endParaRPr lang="en-US" sz="1600" dirty="0"/>
                     </a:p>
                   </a:txBody>
-                  <a:tcPr marL="91440" marR="91440" marT="45720" marB="45720" anchor="ctr">
+                  <a:tcPr anchor="ctr">
                     <a:lnL w="12700" cap="flat" cmpd="sng" algn="ctr">
                       <a:solidFill>
                         <a:srgbClr val="E2E8F0"/>
@@ -5501,7 +5263,7 @@
                     <a:bodyPr/>
                     <a:lstStyle/>
                     <a:p>
-                      <a:pPr algn="l" indent="0" marL="0">
+                      <a:pPr marL="0" indent="0" algn="l">
                         <a:buNone/>
                       </a:pPr>
                       <a:r>
@@ -5515,7 +5277,7 @@
                       <a:endParaRPr lang="en-US" sz="1600" dirty="0"/>
                     </a:p>
                   </a:txBody>
-                  <a:tcPr marL="91440" marR="91440" marT="45720" marB="45720" anchor="ctr">
+                  <a:tcPr anchor="ctr">
                     <a:lnL w="12700" cap="flat" cmpd="sng" algn="ctr">
                       <a:solidFill>
                         <a:srgbClr val="E2E8F0"/>
@@ -5562,7 +5324,7 @@
                     <a:bodyPr/>
                     <a:lstStyle/>
                     <a:p>
-                      <a:pPr algn="l" indent="0" marL="0">
+                      <a:pPr marL="0" indent="0" algn="l">
                         <a:buNone/>
                       </a:pPr>
                       <a:r>
@@ -5576,7 +5338,7 @@
                       <a:endParaRPr lang="en-US" sz="1600" dirty="0"/>
                     </a:p>
                   </a:txBody>
-                  <a:tcPr marL="91440" marR="91440" marT="45720" marB="45720" anchor="ctr">
+                  <a:tcPr anchor="ctr">
                     <a:lnL w="12700" cap="flat" cmpd="sng" algn="ctr">
                       <a:solidFill>
                         <a:srgbClr val="E2E8F0"/>
@@ -5618,6 +5380,11 @@
                     </a:solidFill>
                   </a:tcPr>
                 </a:tc>
+                <a:extLst>
+                  <a:ext uri="{0D108BD9-81ED-4DB2-BD59-A6C34878D82A}">
+                    <a16:rowId xmlns:a16="http://schemas.microsoft.com/office/drawing/2014/main" val="10000"/>
+                  </a:ext>
+                </a:extLst>
               </a:tr>
               <a:tr h="411480">
                 <a:tc>
@@ -5625,7 +5392,7 @@
                     <a:bodyPr/>
                     <a:lstStyle/>
                     <a:p>
-                      <a:pPr algn="l" indent="0" marL="0">
+                      <a:pPr marL="0" indent="0" algn="l">
                         <a:buNone/>
                       </a:pPr>
                       <a:r>
@@ -5639,7 +5406,7 @@
                       <a:endParaRPr lang="en-US" sz="1600" dirty="0"/>
                     </a:p>
                   </a:txBody>
-                  <a:tcPr marL="91440" marR="91440" marT="45720" marB="45720" anchor="ctr">
+                  <a:tcPr anchor="ctr">
                     <a:lnL w="12700" cap="flat" cmpd="sng" algn="ctr">
                       <a:solidFill>
                         <a:srgbClr val="E2E8F0"/>
@@ -5686,7 +5453,7 @@
                     <a:bodyPr/>
                     <a:lstStyle/>
                     <a:p>
-                      <a:pPr algn="l" indent="0" marL="0">
+                      <a:pPr marL="0" indent="0" algn="l">
                         <a:buNone/>
                       </a:pPr>
                       <a:r>
@@ -5700,7 +5467,7 @@
                       <a:endParaRPr lang="en-US" sz="1600" dirty="0"/>
                     </a:p>
                   </a:txBody>
-                  <a:tcPr marL="91440" marR="91440" marT="45720" marB="45720" anchor="ctr">
+                  <a:tcPr anchor="ctr">
                     <a:lnL w="12700" cap="flat" cmpd="sng" algn="ctr">
                       <a:solidFill>
                         <a:srgbClr val="E2E8F0"/>
@@ -5747,7 +5514,7 @@
                     <a:bodyPr/>
                     <a:lstStyle/>
                     <a:p>
-                      <a:pPr algn="l" indent="0" marL="0">
+                      <a:pPr marL="0" indent="0" algn="l">
                         <a:buNone/>
                       </a:pPr>
                       <a:r>
@@ -5761,7 +5528,7 @@
                       <a:endParaRPr lang="en-US" sz="1600" dirty="0"/>
                     </a:p>
                   </a:txBody>
-                  <a:tcPr marL="91440" marR="91440" marT="45720" marB="45720" anchor="ctr">
+                  <a:tcPr anchor="ctr">
                     <a:lnL w="12700" cap="flat" cmpd="sng" algn="ctr">
                       <a:solidFill>
                         <a:srgbClr val="E2E8F0"/>
@@ -5803,6 +5570,11 @@
                     </a:solidFill>
                   </a:tcPr>
                 </a:tc>
+                <a:extLst>
+                  <a:ext uri="{0D108BD9-81ED-4DB2-BD59-A6C34878D82A}">
+                    <a16:rowId xmlns:a16="http://schemas.microsoft.com/office/drawing/2014/main" val="10001"/>
+                  </a:ext>
+                </a:extLst>
               </a:tr>
               <a:tr h="411480">
                 <a:tc>
@@ -5810,7 +5582,7 @@
                     <a:bodyPr/>
                     <a:lstStyle/>
                     <a:p>
-                      <a:pPr algn="l" indent="0" marL="0">
+                      <a:pPr marL="0" indent="0" algn="l">
                         <a:buNone/>
                       </a:pPr>
                       <a:r>
@@ -5824,7 +5596,7 @@
                       <a:endParaRPr lang="en-US" sz="1600" dirty="0"/>
                     </a:p>
                   </a:txBody>
-                  <a:tcPr marL="91440" marR="91440" marT="45720" marB="45720" anchor="ctr">
+                  <a:tcPr anchor="ctr">
                     <a:lnL w="12700" cap="flat" cmpd="sng" algn="ctr">
                       <a:solidFill>
                         <a:srgbClr val="E2E8F0"/>
@@ -5871,7 +5643,7 @@
                     <a:bodyPr/>
                     <a:lstStyle/>
                     <a:p>
-                      <a:pPr algn="l" indent="0" marL="0">
+                      <a:pPr marL="0" indent="0" algn="l">
                         <a:buNone/>
                       </a:pPr>
                       <a:r>
@@ -5885,7 +5657,7 @@
                       <a:endParaRPr lang="en-US" sz="1600" dirty="0"/>
                     </a:p>
                   </a:txBody>
-                  <a:tcPr marL="91440" marR="91440" marT="45720" marB="45720" anchor="ctr">
+                  <a:tcPr anchor="ctr">
                     <a:lnL w="12700" cap="flat" cmpd="sng" algn="ctr">
                       <a:solidFill>
                         <a:srgbClr val="E2E8F0"/>
@@ -5932,7 +5704,7 @@
                     <a:bodyPr/>
                     <a:lstStyle/>
                     <a:p>
-                      <a:pPr algn="l" indent="0" marL="0">
+                      <a:pPr marL="0" indent="0" algn="l">
                         <a:buNone/>
                       </a:pPr>
                       <a:r>
@@ -5946,7 +5718,7 @@
                       <a:endParaRPr lang="en-US" sz="1600" dirty="0"/>
                     </a:p>
                   </a:txBody>
-                  <a:tcPr marL="91440" marR="91440" marT="45720" marB="45720" anchor="ctr">
+                  <a:tcPr anchor="ctr">
                     <a:lnL w="12700" cap="flat" cmpd="sng" algn="ctr">
                       <a:solidFill>
                         <a:srgbClr val="E2E8F0"/>
@@ -5988,6 +5760,11 @@
                     </a:solidFill>
                   </a:tcPr>
                 </a:tc>
+                <a:extLst>
+                  <a:ext uri="{0D108BD9-81ED-4DB2-BD59-A6C34878D82A}">
+                    <a16:rowId xmlns:a16="http://schemas.microsoft.com/office/drawing/2014/main" val="10002"/>
+                  </a:ext>
+                </a:extLst>
               </a:tr>
               <a:tr h="411480">
                 <a:tc>
@@ -5995,7 +5772,7 @@
                     <a:bodyPr/>
                     <a:lstStyle/>
                     <a:p>
-                      <a:pPr algn="l" indent="0" marL="0">
+                      <a:pPr marL="0" indent="0" algn="l">
                         <a:buNone/>
                       </a:pPr>
                       <a:r>
@@ -6009,7 +5786,7 @@
                       <a:endParaRPr lang="en-US" sz="1600" dirty="0"/>
                     </a:p>
                   </a:txBody>
-                  <a:tcPr marL="91440" marR="91440" marT="45720" marB="45720" anchor="ctr">
+                  <a:tcPr anchor="ctr">
                     <a:lnL w="12700" cap="flat" cmpd="sng" algn="ctr">
                       <a:solidFill>
                         <a:srgbClr val="E2E8F0"/>
@@ -6056,7 +5833,7 @@
                     <a:bodyPr/>
                     <a:lstStyle/>
                     <a:p>
-                      <a:pPr algn="l" indent="0" marL="0">
+                      <a:pPr marL="0" indent="0" algn="l">
                         <a:buNone/>
                       </a:pPr>
                       <a:r>
@@ -6070,7 +5847,7 @@
                       <a:endParaRPr lang="en-US" sz="1600" dirty="0"/>
                     </a:p>
                   </a:txBody>
-                  <a:tcPr marL="91440" marR="91440" marT="45720" marB="45720" anchor="ctr">
+                  <a:tcPr anchor="ctr">
                     <a:lnL w="12700" cap="flat" cmpd="sng" algn="ctr">
                       <a:solidFill>
                         <a:srgbClr val="E2E8F0"/>
@@ -6117,7 +5894,7 @@
                     <a:bodyPr/>
                     <a:lstStyle/>
                     <a:p>
-                      <a:pPr algn="l" indent="0" marL="0">
+                      <a:pPr marL="0" indent="0" algn="l">
                         <a:buNone/>
                       </a:pPr>
                       <a:r>
@@ -6131,7 +5908,7 @@
                       <a:endParaRPr lang="en-US" sz="1600" dirty="0"/>
                     </a:p>
                   </a:txBody>
-                  <a:tcPr marL="91440" marR="91440" marT="45720" marB="45720" anchor="ctr">
+                  <a:tcPr anchor="ctr">
                     <a:lnL w="12700" cap="flat" cmpd="sng" algn="ctr">
                       <a:solidFill>
                         <a:srgbClr val="E2E8F0"/>
@@ -6173,6 +5950,11 @@
                     </a:solidFill>
                   </a:tcPr>
                 </a:tc>
+                <a:extLst>
+                  <a:ext uri="{0D108BD9-81ED-4DB2-BD59-A6C34878D82A}">
+                    <a16:rowId xmlns:a16="http://schemas.microsoft.com/office/drawing/2014/main" val="10003"/>
+                  </a:ext>
+                </a:extLst>
               </a:tr>
               <a:tr h="411480">
                 <a:tc>
@@ -6180,7 +5962,7 @@
                     <a:bodyPr/>
                     <a:lstStyle/>
                     <a:p>
-                      <a:pPr algn="l" indent="0" marL="0">
+                      <a:pPr marL="0" indent="0" algn="l">
                         <a:buNone/>
                       </a:pPr>
                       <a:r>
@@ -6194,7 +5976,7 @@
                       <a:endParaRPr lang="en-US" sz="1600" dirty="0"/>
                     </a:p>
                   </a:txBody>
-                  <a:tcPr marL="91440" marR="91440" marT="45720" marB="45720" anchor="ctr">
+                  <a:tcPr anchor="ctr">
                     <a:lnL w="12700" cap="flat" cmpd="sng" algn="ctr">
                       <a:solidFill>
                         <a:srgbClr val="E2E8F0"/>
@@ -6241,7 +6023,7 @@
                     <a:bodyPr/>
                     <a:lstStyle/>
                     <a:p>
-                      <a:pPr algn="l" indent="0" marL="0">
+                      <a:pPr marL="0" indent="0" algn="l">
                         <a:buNone/>
                       </a:pPr>
                       <a:r>
@@ -6255,7 +6037,7 @@
                       <a:endParaRPr lang="en-US" sz="1600" dirty="0"/>
                     </a:p>
                   </a:txBody>
-                  <a:tcPr marL="91440" marR="91440" marT="45720" marB="45720" anchor="ctr">
+                  <a:tcPr anchor="ctr">
                     <a:lnL w="12700" cap="flat" cmpd="sng" algn="ctr">
                       <a:solidFill>
                         <a:srgbClr val="E2E8F0"/>
@@ -6302,7 +6084,7 @@
                     <a:bodyPr/>
                     <a:lstStyle/>
                     <a:p>
-                      <a:pPr algn="l" indent="0" marL="0">
+                      <a:pPr marL="0" indent="0" algn="l">
                         <a:buNone/>
                       </a:pPr>
                       <a:r>
@@ -6316,7 +6098,7 @@
                       <a:endParaRPr lang="en-US" sz="1600" dirty="0"/>
                     </a:p>
                   </a:txBody>
-                  <a:tcPr marL="91440" marR="91440" marT="45720" marB="45720" anchor="ctr">
+                  <a:tcPr anchor="ctr">
                     <a:lnL w="12700" cap="flat" cmpd="sng" algn="ctr">
                       <a:solidFill>
                         <a:srgbClr val="E2E8F0"/>
@@ -6358,6 +6140,11 @@
                     </a:solidFill>
                   </a:tcPr>
                 </a:tc>
+                <a:extLst>
+                  <a:ext uri="{0D108BD9-81ED-4DB2-BD59-A6C34878D82A}">
+                    <a16:rowId xmlns:a16="http://schemas.microsoft.com/office/drawing/2014/main" val="10004"/>
+                  </a:ext>
+                </a:extLst>
               </a:tr>
               <a:tr h="411480">
                 <a:tc>
@@ -6365,7 +6152,7 @@
                     <a:bodyPr/>
                     <a:lstStyle/>
                     <a:p>
-                      <a:pPr algn="l" indent="0" marL="0">
+                      <a:pPr marL="0" indent="0" algn="l">
                         <a:buNone/>
                       </a:pPr>
                       <a:r>
@@ -6379,7 +6166,7 @@
                       <a:endParaRPr lang="en-US" sz="1600" dirty="0"/>
                     </a:p>
                   </a:txBody>
-                  <a:tcPr marL="91440" marR="91440" marT="45720" marB="45720" anchor="ctr">
+                  <a:tcPr anchor="ctr">
                     <a:lnL w="12700" cap="flat" cmpd="sng" algn="ctr">
                       <a:solidFill>
                         <a:srgbClr val="E2E8F0"/>
@@ -6426,7 +6213,7 @@
                     <a:bodyPr/>
                     <a:lstStyle/>
                     <a:p>
-                      <a:pPr algn="l" indent="0" marL="0">
+                      <a:pPr marL="0" indent="0" algn="l">
                         <a:buNone/>
                       </a:pPr>
                       <a:r>
@@ -6440,7 +6227,7 @@
                       <a:endParaRPr lang="en-US" sz="1600" dirty="0"/>
                     </a:p>
                   </a:txBody>
-                  <a:tcPr marL="91440" marR="91440" marT="45720" marB="45720" anchor="ctr">
+                  <a:tcPr anchor="ctr">
                     <a:lnL w="12700" cap="flat" cmpd="sng" algn="ctr">
                       <a:solidFill>
                         <a:srgbClr val="E2E8F0"/>
@@ -6487,7 +6274,7 @@
                     <a:bodyPr/>
                     <a:lstStyle/>
                     <a:p>
-                      <a:pPr algn="l" indent="0" marL="0">
+                      <a:pPr marL="0" indent="0" algn="l">
                         <a:buNone/>
                       </a:pPr>
                       <a:r>
@@ -6501,7 +6288,7 @@
                       <a:endParaRPr lang="en-US" sz="1600" dirty="0"/>
                     </a:p>
                   </a:txBody>
-                  <a:tcPr marL="91440" marR="91440" marT="45720" marB="45720" anchor="ctr">
+                  <a:tcPr anchor="ctr">
                     <a:lnL w="12700" cap="flat" cmpd="sng" algn="ctr">
                       <a:solidFill>
                         <a:srgbClr val="E2E8F0"/>
@@ -6543,6 +6330,11 @@
                     </a:solidFill>
                   </a:tcPr>
                 </a:tc>
+                <a:extLst>
+                  <a:ext uri="{0D108BD9-81ED-4DB2-BD59-A6C34878D82A}">
+                    <a16:rowId xmlns:a16="http://schemas.microsoft.com/office/drawing/2014/main" val="10005"/>
+                  </a:ext>
+                </a:extLst>
               </a:tr>
               <a:tr h="411480">
                 <a:tc>
@@ -6550,7 +6342,7 @@
                     <a:bodyPr/>
                     <a:lstStyle/>
                     <a:p>
-                      <a:pPr algn="l" indent="0" marL="0">
+                      <a:pPr marL="0" indent="0" algn="l">
                         <a:buNone/>
                       </a:pPr>
                       <a:r>
@@ -6564,7 +6356,7 @@
                       <a:endParaRPr lang="en-US" sz="1600" dirty="0"/>
                     </a:p>
                   </a:txBody>
-                  <a:tcPr marL="91440" marR="91440" marT="45720" marB="45720" anchor="ctr">
+                  <a:tcPr anchor="ctr">
                     <a:lnL w="12700" cap="flat" cmpd="sng" algn="ctr">
                       <a:solidFill>
                         <a:srgbClr val="E2E8F0"/>
@@ -6611,7 +6403,7 @@
                     <a:bodyPr/>
                     <a:lstStyle/>
                     <a:p>
-                      <a:pPr algn="l" indent="0" marL="0">
+                      <a:pPr marL="0" indent="0" algn="l">
                         <a:buNone/>
                       </a:pPr>
                       <a:r>
@@ -6625,7 +6417,7 @@
                       <a:endParaRPr lang="en-US" sz="1600" dirty="0"/>
                     </a:p>
                   </a:txBody>
-                  <a:tcPr marL="91440" marR="91440" marT="45720" marB="45720" anchor="ctr">
+                  <a:tcPr anchor="ctr">
                     <a:lnL w="12700" cap="flat" cmpd="sng" algn="ctr">
                       <a:solidFill>
                         <a:srgbClr val="E2E8F0"/>
@@ -6672,7 +6464,7 @@
                     <a:bodyPr/>
                     <a:lstStyle/>
                     <a:p>
-                      <a:pPr algn="l" indent="0" marL="0">
+                      <a:pPr marL="0" indent="0" algn="l">
                         <a:buNone/>
                       </a:pPr>
                       <a:r>
@@ -6686,7 +6478,7 @@
                       <a:endParaRPr lang="en-US" sz="1600" dirty="0"/>
                     </a:p>
                   </a:txBody>
-                  <a:tcPr marL="91440" marR="91440" marT="45720" marB="45720" anchor="ctr">
+                  <a:tcPr anchor="ctr">
                     <a:lnL w="12700" cap="flat" cmpd="sng" algn="ctr">
                       <a:solidFill>
                         <a:srgbClr val="E2E8F0"/>
@@ -6728,6 +6520,11 @@
                     </a:solidFill>
                   </a:tcPr>
                 </a:tc>
+                <a:extLst>
+                  <a:ext uri="{0D108BD9-81ED-4DB2-BD59-A6C34878D82A}">
+                    <a16:rowId xmlns:a16="http://schemas.microsoft.com/office/drawing/2014/main" val="10006"/>
+                  </a:ext>
+                </a:extLst>
               </a:tr>
               <a:tr h="411480">
                 <a:tc>
@@ -6735,7 +6532,7 @@
                     <a:bodyPr/>
                     <a:lstStyle/>
                     <a:p>
-                      <a:pPr algn="l" indent="0" marL="0">
+                      <a:pPr marL="0" indent="0" algn="l">
                         <a:buNone/>
                       </a:pPr>
                       <a:r>
@@ -6749,7 +6546,7 @@
                       <a:endParaRPr lang="en-US" sz="1600" dirty="0"/>
                     </a:p>
                   </a:txBody>
-                  <a:tcPr marL="91440" marR="91440" marT="45720" marB="45720" anchor="ctr">
+                  <a:tcPr anchor="ctr">
                     <a:lnL w="12700" cap="flat" cmpd="sng" algn="ctr">
                       <a:solidFill>
                         <a:srgbClr val="E2E8F0"/>
@@ -6796,7 +6593,7 @@
                     <a:bodyPr/>
                     <a:lstStyle/>
                     <a:p>
-                      <a:pPr algn="l" indent="0" marL="0">
+                      <a:pPr marL="0" indent="0" algn="l">
                         <a:buNone/>
                       </a:pPr>
                       <a:r>
@@ -6810,7 +6607,7 @@
                       <a:endParaRPr lang="en-US" sz="1600" dirty="0"/>
                     </a:p>
                   </a:txBody>
-                  <a:tcPr marL="91440" marR="91440" marT="45720" marB="45720" anchor="ctr">
+                  <a:tcPr anchor="ctr">
                     <a:lnL w="12700" cap="flat" cmpd="sng" algn="ctr">
                       <a:solidFill>
                         <a:srgbClr val="E2E8F0"/>
@@ -6857,7 +6654,7 @@
                     <a:bodyPr/>
                     <a:lstStyle/>
                     <a:p>
-                      <a:pPr algn="l" indent="0" marL="0">
+                      <a:pPr marL="0" indent="0" algn="l">
                         <a:buNone/>
                       </a:pPr>
                       <a:r>
@@ -6871,7 +6668,7 @@
                       <a:endParaRPr lang="en-US" sz="1600" dirty="0"/>
                     </a:p>
                   </a:txBody>
-                  <a:tcPr marL="91440" marR="91440" marT="45720" marB="45720" anchor="ctr">
+                  <a:tcPr anchor="ctr">
                     <a:lnL w="12700" cap="flat" cmpd="sng" algn="ctr">
                       <a:solidFill>
                         <a:srgbClr val="E2E8F0"/>
@@ -6913,6 +6710,11 @@
                     </a:solidFill>
                   </a:tcPr>
                 </a:tc>
+                <a:extLst>
+                  <a:ext uri="{0D108BD9-81ED-4DB2-BD59-A6C34878D82A}">
+                    <a16:rowId xmlns:a16="http://schemas.microsoft.com/office/drawing/2014/main" val="10007"/>
+                  </a:ext>
+                </a:extLst>
               </a:tr>
             </a:tbl>
           </a:graphicData>
@@ -6934,6 +6736,7 @@
         <a:solidFill>
           <a:srgbClr val="FFFFFF"/>
         </a:solidFill>
+        <a:effectLst/>
       </p:bgPr>
     </p:bg>
     <p:spTree>
@@ -6971,7 +6774,7 @@
           <a:bodyPr wrap="square" lIns="0" tIns="0" rIns="0" bIns="0" rtlCol="0" anchor="ctr"/>
           <a:lstStyle/>
           <a:p>
-            <a:pPr indent="0" marL="0">
+            <a:pPr marL="0" indent="0">
               <a:buNone/>
             </a:pPr>
             <a:r>
@@ -7013,7 +6816,7 @@
             <a:prstDash val="solid"/>
           </a:ln>
           <a:effectLst>
-            <a:outerShdw sx="100000" sy="100000" kx="0" ky="0" algn="bl" rotWithShape="0" blurRad="76200" dist="25400" dir="8100000">
+            <a:outerShdw blurRad="76200" dist="25400" dir="8100000" algn="bl" rotWithShape="0">
               <a:srgbClr val="000000">
                 <a:alpha val="12000"/>
               </a:srgbClr>
@@ -7062,7 +6865,7 @@
           <a:bodyPr wrap="square" lIns="0" tIns="0" rIns="0" bIns="0" rtlCol="0" anchor="ctr"/>
           <a:lstStyle/>
           <a:p>
-            <a:pPr algn="l" indent="0" marL="0">
+            <a:pPr marL="0" indent="0" algn="l">
               <a:buNone/>
             </a:pPr>
             <a:r>
@@ -7101,7 +6904,7 @@
           <a:bodyPr wrap="square" lIns="0" tIns="0" rIns="0" bIns="0" rtlCol="0" anchor="ctr"/>
           <a:lstStyle/>
           <a:p>
-            <a:pPr algn="l" indent="0" marL="0">
+            <a:pPr marL="0" indent="0" algn="l">
               <a:buNone/>
             </a:pPr>
             <a:r>
@@ -7143,7 +6946,7 @@
             <a:prstDash val="solid"/>
           </a:ln>
           <a:effectLst>
-            <a:outerShdw sx="100000" sy="100000" kx="0" ky="0" algn="bl" rotWithShape="0" blurRad="76200" dist="25400" dir="8100000">
+            <a:outerShdw blurRad="76200" dist="25400" dir="8100000" algn="bl" rotWithShape="0">
               <a:srgbClr val="000000">
                 <a:alpha val="12000"/>
               </a:srgbClr>
@@ -7192,7 +6995,7 @@
           <a:bodyPr wrap="square" lIns="0" tIns="0" rIns="0" bIns="0" rtlCol="0" anchor="ctr"/>
           <a:lstStyle/>
           <a:p>
-            <a:pPr algn="l" indent="0" marL="0">
+            <a:pPr marL="0" indent="0" algn="l">
               <a:buNone/>
             </a:pPr>
             <a:r>
@@ -7231,7 +7034,7 @@
           <a:bodyPr wrap="square" lIns="0" tIns="0" rIns="0" bIns="0" rtlCol="0" anchor="ctr"/>
           <a:lstStyle/>
           <a:p>
-            <a:pPr algn="l" indent="0" marL="0">
+            <a:pPr marL="0" indent="0" algn="l">
               <a:buNone/>
             </a:pPr>
             <a:r>
@@ -7273,7 +7076,7 @@
             <a:prstDash val="solid"/>
           </a:ln>
           <a:effectLst>
-            <a:outerShdw sx="100000" sy="100000" kx="0" ky="0" algn="bl" rotWithShape="0" blurRad="76200" dist="25400" dir="8100000">
+            <a:outerShdw blurRad="76200" dist="25400" dir="8100000" algn="bl" rotWithShape="0">
               <a:srgbClr val="000000">
                 <a:alpha val="12000"/>
               </a:srgbClr>
@@ -7322,7 +7125,7 @@
           <a:bodyPr wrap="square" lIns="0" tIns="0" rIns="0" bIns="0" rtlCol="0" anchor="ctr"/>
           <a:lstStyle/>
           <a:p>
-            <a:pPr algn="l" indent="0" marL="0">
+            <a:pPr marL="0" indent="0" algn="l">
               <a:buNone/>
             </a:pPr>
             <a:r>
@@ -7361,7 +7164,7 @@
           <a:bodyPr wrap="square" lIns="0" tIns="0" rIns="0" bIns="0" rtlCol="0" anchor="ctr"/>
           <a:lstStyle/>
           <a:p>
-            <a:pPr algn="l" indent="0" marL="0">
+            <a:pPr marL="0" indent="0" algn="l">
               <a:buNone/>
             </a:pPr>
             <a:r>
@@ -7381,7 +7184,7 @@
       </p:sp>
       <p:graphicFrame>
         <p:nvGraphicFramePr>
-          <p:cNvPr id="5" name="Table 0"/>
+          <p:cNvPr id="15" name="Table 0"/>
           <p:cNvGraphicFramePr>
             <a:graphicFrameLocks noGrp="1"/>
           </p:cNvGraphicFramePr>
@@ -7402,8 +7205,20 @@
             <a:tbl>
               <a:tblPr/>
               <a:tblGrid>
-                <a:gridCol w="3749040"/>
-                <a:gridCol w="1097280"/>
+                <a:gridCol w="3749040">
+                  <a:extLst>
+                    <a:ext uri="{9D8B030D-6E8A-4147-A177-3AD203B41FA5}">
+                      <a16:colId xmlns:a16="http://schemas.microsoft.com/office/drawing/2014/main" val="20000"/>
+                    </a:ext>
+                  </a:extLst>
+                </a:gridCol>
+                <a:gridCol w="1097280">
+                  <a:extLst>
+                    <a:ext uri="{9D8B030D-6E8A-4147-A177-3AD203B41FA5}">
+                      <a16:colId xmlns:a16="http://schemas.microsoft.com/office/drawing/2014/main" val="20001"/>
+                    </a:ext>
+                  </a:extLst>
+                </a:gridCol>
               </a:tblGrid>
               <a:tr h="594360">
                 <a:tc>
@@ -7411,7 +7226,7 @@
                     <a:bodyPr/>
                     <a:lstStyle/>
                     <a:p>
-                      <a:pPr algn="l" indent="0" marL="0">
+                      <a:pPr marL="0" indent="0" algn="l">
                         <a:buNone/>
                       </a:pPr>
                       <a:r>
@@ -7425,7 +7240,7 @@
                       <a:endParaRPr lang="en-US" sz="1300" dirty="0"/>
                     </a:p>
                   </a:txBody>
-                  <a:tcPr marL="91440" marR="91440" marT="45720" marB="45720" anchor="ctr">
+                  <a:tcPr anchor="ctr">
                     <a:lnL w="12700" cap="flat" cmpd="sng" algn="ctr">
                       <a:solidFill>
                         <a:srgbClr val="E2E8F0"/>
@@ -7472,7 +7287,7 @@
                     <a:bodyPr/>
                     <a:lstStyle/>
                     <a:p>
-                      <a:pPr algn="l" indent="0" marL="0">
+                      <a:pPr marL="0" indent="0" algn="l">
                         <a:buNone/>
                       </a:pPr>
                       <a:r>
@@ -7486,7 +7301,7 @@
                       <a:endParaRPr lang="en-US" sz="1300" dirty="0"/>
                     </a:p>
                   </a:txBody>
-                  <a:tcPr marL="91440" marR="91440" marT="45720" marB="45720" anchor="ctr">
+                  <a:tcPr anchor="ctr">
                     <a:lnL w="12700" cap="flat" cmpd="sng" algn="ctr">
                       <a:solidFill>
                         <a:srgbClr val="E2E8F0"/>
@@ -7528,6 +7343,11 @@
                     </a:solidFill>
                   </a:tcPr>
                 </a:tc>
+                <a:extLst>
+                  <a:ext uri="{0D108BD9-81ED-4DB2-BD59-A6C34878D82A}">
+                    <a16:rowId xmlns:a16="http://schemas.microsoft.com/office/drawing/2014/main" val="10000"/>
+                  </a:ext>
+                </a:extLst>
               </a:tr>
               <a:tr h="594360">
                 <a:tc>
@@ -7535,7 +7355,7 @@
                     <a:bodyPr/>
                     <a:lstStyle/>
                     <a:p>
-                      <a:pPr algn="l" indent="0" marL="0">
+                      <a:pPr marL="0" indent="0" algn="l">
                         <a:buNone/>
                       </a:pPr>
                       <a:r>
@@ -7549,7 +7369,7 @@
                       <a:endParaRPr lang="en-US" sz="1300" dirty="0"/>
                     </a:p>
                   </a:txBody>
-                  <a:tcPr marL="91440" marR="91440" marT="45720" marB="45720" anchor="ctr">
+                  <a:tcPr anchor="ctr">
                     <a:lnL w="12700" cap="flat" cmpd="sng" algn="ctr">
                       <a:solidFill>
                         <a:srgbClr val="E2E8F0"/>
@@ -7596,7 +7416,7 @@
                     <a:bodyPr/>
                     <a:lstStyle/>
                     <a:p>
-                      <a:pPr algn="l" indent="0" marL="0">
+                      <a:pPr marL="0" indent="0" algn="l">
                         <a:buNone/>
                       </a:pPr>
                       <a:r>
@@ -7610,7 +7430,7 @@
                       <a:endParaRPr lang="en-US" sz="1300" dirty="0"/>
                     </a:p>
                   </a:txBody>
-                  <a:tcPr marL="91440" marR="91440" marT="45720" marB="45720" anchor="ctr">
+                  <a:tcPr anchor="ctr">
                     <a:lnL w="12700" cap="flat" cmpd="sng" algn="ctr">
                       <a:solidFill>
                         <a:srgbClr val="E2E8F0"/>
@@ -7652,6 +7472,11 @@
                     </a:solidFill>
                   </a:tcPr>
                 </a:tc>
+                <a:extLst>
+                  <a:ext uri="{0D108BD9-81ED-4DB2-BD59-A6C34878D82A}">
+                    <a16:rowId xmlns:a16="http://schemas.microsoft.com/office/drawing/2014/main" val="10001"/>
+                  </a:ext>
+                </a:extLst>
               </a:tr>
               <a:tr h="594360">
                 <a:tc>
@@ -7659,7 +7484,7 @@
                     <a:bodyPr/>
                     <a:lstStyle/>
                     <a:p>
-                      <a:pPr algn="l" indent="0" marL="0">
+                      <a:pPr marL="0" indent="0" algn="l">
                         <a:buNone/>
                       </a:pPr>
                       <a:r>
@@ -7673,7 +7498,7 @@
                       <a:endParaRPr lang="en-US" sz="1300" dirty="0"/>
                     </a:p>
                   </a:txBody>
-                  <a:tcPr marL="91440" marR="91440" marT="45720" marB="45720" anchor="ctr">
+                  <a:tcPr anchor="ctr">
                     <a:lnL w="12700" cap="flat" cmpd="sng" algn="ctr">
                       <a:solidFill>
                         <a:srgbClr val="E2E8F0"/>
@@ -7720,7 +7545,7 @@
                     <a:bodyPr/>
                     <a:lstStyle/>
                     <a:p>
-                      <a:pPr algn="l" indent="0" marL="0">
+                      <a:pPr marL="0" indent="0" algn="l">
                         <a:buNone/>
                       </a:pPr>
                       <a:r>
@@ -7734,7 +7559,7 @@
                       <a:endParaRPr lang="en-US" sz="1300" dirty="0"/>
                     </a:p>
                   </a:txBody>
-                  <a:tcPr marL="91440" marR="91440" marT="45720" marB="45720" anchor="ctr">
+                  <a:tcPr anchor="ctr">
                     <a:lnL w="12700" cap="flat" cmpd="sng" algn="ctr">
                       <a:solidFill>
                         <a:srgbClr val="E2E8F0"/>
@@ -7776,6 +7601,11 @@
                     </a:solidFill>
                   </a:tcPr>
                 </a:tc>
+                <a:extLst>
+                  <a:ext uri="{0D108BD9-81ED-4DB2-BD59-A6C34878D82A}">
+                    <a16:rowId xmlns:a16="http://schemas.microsoft.com/office/drawing/2014/main" val="10002"/>
+                  </a:ext>
+                </a:extLst>
               </a:tr>
               <a:tr h="594360">
                 <a:tc>
@@ -7783,7 +7613,7 @@
                     <a:bodyPr/>
                     <a:lstStyle/>
                     <a:p>
-                      <a:pPr algn="l" indent="0" marL="0">
+                      <a:pPr marL="0" indent="0" algn="l">
                         <a:buNone/>
                       </a:pPr>
                       <a:r>
@@ -7797,7 +7627,7 @@
                       <a:endParaRPr lang="en-US" sz="1300" dirty="0"/>
                     </a:p>
                   </a:txBody>
-                  <a:tcPr marL="91440" marR="91440" marT="45720" marB="45720" anchor="ctr">
+                  <a:tcPr anchor="ctr">
                     <a:lnL w="12700" cap="flat" cmpd="sng" algn="ctr">
                       <a:solidFill>
                         <a:srgbClr val="E2E8F0"/>
@@ -7844,7 +7674,7 @@
                     <a:bodyPr/>
                     <a:lstStyle/>
                     <a:p>
-                      <a:pPr algn="l" indent="0" marL="0">
+                      <a:pPr marL="0" indent="0" algn="l">
                         <a:buNone/>
                       </a:pPr>
                       <a:r>
@@ -7858,7 +7688,7 @@
                       <a:endParaRPr lang="en-US" sz="1300" dirty="0"/>
                     </a:p>
                   </a:txBody>
-                  <a:tcPr marL="91440" marR="91440" marT="45720" marB="45720" anchor="ctr">
+                  <a:tcPr anchor="ctr">
                     <a:lnL w="12700" cap="flat" cmpd="sng" algn="ctr">
                       <a:solidFill>
                         <a:srgbClr val="E2E8F0"/>
@@ -7900,6 +7730,11 @@
                     </a:solidFill>
                   </a:tcPr>
                 </a:tc>
+                <a:extLst>
+                  <a:ext uri="{0D108BD9-81ED-4DB2-BD59-A6C34878D82A}">
+                    <a16:rowId xmlns:a16="http://schemas.microsoft.com/office/drawing/2014/main" val="10003"/>
+                  </a:ext>
+                </a:extLst>
               </a:tr>
               <a:tr h="594360">
                 <a:tc>
@@ -7907,7 +7742,7 @@
                     <a:bodyPr/>
                     <a:lstStyle/>
                     <a:p>
-                      <a:pPr algn="l" indent="0" marL="0">
+                      <a:pPr marL="0" indent="0" algn="l">
                         <a:buNone/>
                       </a:pPr>
                       <a:r>
@@ -7921,7 +7756,7 @@
                       <a:endParaRPr lang="en-US" sz="1300" dirty="0"/>
                     </a:p>
                   </a:txBody>
-                  <a:tcPr marL="91440" marR="91440" marT="45720" marB="45720" anchor="ctr">
+                  <a:tcPr anchor="ctr">
                     <a:lnL w="12700" cap="flat" cmpd="sng" algn="ctr">
                       <a:solidFill>
                         <a:srgbClr val="E2E8F0"/>
@@ -7968,7 +7803,7 @@
                     <a:bodyPr/>
                     <a:lstStyle/>
                     <a:p>
-                      <a:pPr algn="l" indent="0" marL="0">
+                      <a:pPr marL="0" indent="0" algn="l">
                         <a:buNone/>
                       </a:pPr>
                       <a:r>
@@ -7982,7 +7817,7 @@
                       <a:endParaRPr lang="en-US" sz="1300" dirty="0"/>
                     </a:p>
                   </a:txBody>
-                  <a:tcPr marL="91440" marR="91440" marT="45720" marB="45720" anchor="ctr">
+                  <a:tcPr anchor="ctr">
                     <a:lnL w="12700" cap="flat" cmpd="sng" algn="ctr">
                       <a:solidFill>
                         <a:srgbClr val="E2E8F0"/>
@@ -8024,6 +7859,11 @@
                     </a:solidFill>
                   </a:tcPr>
                 </a:tc>
+                <a:extLst>
+                  <a:ext uri="{0D108BD9-81ED-4DB2-BD59-A6C34878D82A}">
+                    <a16:rowId xmlns:a16="http://schemas.microsoft.com/office/drawing/2014/main" val="10004"/>
+                  </a:ext>
+                </a:extLst>
               </a:tr>
               <a:tr h="594360">
                 <a:tc>
@@ -8031,7 +7871,7 @@
                     <a:bodyPr/>
                     <a:lstStyle/>
                     <a:p>
-                      <a:pPr algn="l" indent="0" marL="0">
+                      <a:pPr marL="0" indent="0" algn="l">
                         <a:buNone/>
                       </a:pPr>
                       <a:r>
@@ -8045,7 +7885,7 @@
                       <a:endParaRPr lang="en-US" sz="1300" dirty="0"/>
                     </a:p>
                   </a:txBody>
-                  <a:tcPr marL="91440" marR="91440" marT="45720" marB="45720" anchor="ctr">
+                  <a:tcPr anchor="ctr">
                     <a:lnL w="12700" cap="flat" cmpd="sng" algn="ctr">
                       <a:solidFill>
                         <a:srgbClr val="E2E8F0"/>
@@ -8092,7 +7932,7 @@
                     <a:bodyPr/>
                     <a:lstStyle/>
                     <a:p>
-                      <a:pPr algn="l" indent="0" marL="0">
+                      <a:pPr marL="0" indent="0" algn="l">
                         <a:buNone/>
                       </a:pPr>
                       <a:r>
@@ -8106,7 +7946,7 @@
                       <a:endParaRPr lang="en-US" sz="1300" dirty="0"/>
                     </a:p>
                   </a:txBody>
-                  <a:tcPr marL="91440" marR="91440" marT="45720" marB="45720" anchor="ctr">
+                  <a:tcPr anchor="ctr">
                     <a:lnL w="12700" cap="flat" cmpd="sng" algn="ctr">
                       <a:solidFill>
                         <a:srgbClr val="E2E8F0"/>
@@ -8148,6 +7988,11 @@
                     </a:solidFill>
                   </a:tcPr>
                 </a:tc>
+                <a:extLst>
+                  <a:ext uri="{0D108BD9-81ED-4DB2-BD59-A6C34878D82A}">
+                    <a16:rowId xmlns:a16="http://schemas.microsoft.com/office/drawing/2014/main" val="10005"/>
+                  </a:ext>
+                </a:extLst>
               </a:tr>
             </a:tbl>
           </a:graphicData>
@@ -8169,6 +8014,7 @@
         <a:solidFill>
           <a:srgbClr val="FFFFFF"/>
         </a:solidFill>
+        <a:effectLst/>
       </p:bgPr>
     </p:bg>
     <p:spTree>
@@ -8206,7 +8052,7 @@
           <a:bodyPr wrap="square" lIns="0" tIns="0" rIns="0" bIns="0" rtlCol="0" anchor="ctr"/>
           <a:lstStyle/>
           <a:p>
-            <a:pPr indent="0" marL="0">
+            <a:pPr marL="0" indent="0">
               <a:buNone/>
             </a:pPr>
             <a:r>
@@ -8270,7 +8116,7 @@
           <a:bodyPr wrap="square" lIns="0" tIns="0" rIns="0" bIns="0" rtlCol="0" anchor="ctr"/>
           <a:lstStyle/>
           <a:p>
-            <a:pPr algn="l" indent="0" marL="0">
+            <a:pPr marL="0" indent="0" algn="l">
               <a:buNone/>
             </a:pPr>
             <a:r>
@@ -8334,7 +8180,7 @@
           <a:bodyPr wrap="square" lIns="0" tIns="0" rIns="0" bIns="0" rtlCol="0" anchor="ctr"/>
           <a:lstStyle/>
           <a:p>
-            <a:pPr algn="l" indent="0" marL="0">
+            <a:pPr marL="0" indent="0" algn="l">
               <a:buNone/>
             </a:pPr>
             <a:r>
@@ -8354,7 +8200,7 @@
       </p:sp>
       <p:graphicFrame>
         <p:nvGraphicFramePr>
-          <p:cNvPr id="6" name="Table 0"/>
+          <p:cNvPr id="7" name="Table 0"/>
           <p:cNvGraphicFramePr>
             <a:graphicFrameLocks noGrp="1"/>
           </p:cNvGraphicFramePr>
@@ -8375,9 +8221,27 @@
             <a:tbl>
               <a:tblPr/>
               <a:tblGrid>
-                <a:gridCol w="4114800"/>
-                <a:gridCol w="2286000"/>
-                <a:gridCol w="1828800"/>
+                <a:gridCol w="4114800">
+                  <a:extLst>
+                    <a:ext uri="{9D8B030D-6E8A-4147-A177-3AD203B41FA5}">
+                      <a16:colId xmlns:a16="http://schemas.microsoft.com/office/drawing/2014/main" val="20000"/>
+                    </a:ext>
+                  </a:extLst>
+                </a:gridCol>
+                <a:gridCol w="2286000">
+                  <a:extLst>
+                    <a:ext uri="{9D8B030D-6E8A-4147-A177-3AD203B41FA5}">
+                      <a16:colId xmlns:a16="http://schemas.microsoft.com/office/drawing/2014/main" val="20001"/>
+                    </a:ext>
+                  </a:extLst>
+                </a:gridCol>
+                <a:gridCol w="1828800">
+                  <a:extLst>
+                    <a:ext uri="{9D8B030D-6E8A-4147-A177-3AD203B41FA5}">
+                      <a16:colId xmlns:a16="http://schemas.microsoft.com/office/drawing/2014/main" val="20002"/>
+                    </a:ext>
+                  </a:extLst>
+                </a:gridCol>
               </a:tblGrid>
               <a:tr h="533400">
                 <a:tc>
@@ -8385,7 +8249,7 @@
                     <a:bodyPr/>
                     <a:lstStyle/>
                     <a:p>
-                      <a:pPr algn="l" indent="0" marL="0">
+                      <a:pPr marL="0" indent="0" algn="l">
                         <a:buNone/>
                       </a:pPr>
                       <a:r>
@@ -8399,7 +8263,7 @@
                       <a:endParaRPr lang="en-US" sz="1400" dirty="0"/>
                     </a:p>
                   </a:txBody>
-                  <a:tcPr marL="91440" marR="91440" marT="45720" marB="45720" anchor="ctr">
+                  <a:tcPr anchor="ctr">
                     <a:lnL w="12700" cap="flat" cmpd="sng" algn="ctr">
                       <a:solidFill>
                         <a:srgbClr val="E2E8F0"/>
@@ -8446,7 +8310,7 @@
                     <a:bodyPr/>
                     <a:lstStyle/>
                     <a:p>
-                      <a:pPr algn="l" indent="0" marL="0">
+                      <a:pPr marL="0" indent="0" algn="l">
                         <a:buNone/>
                       </a:pPr>
                       <a:r>
@@ -8460,7 +8324,7 @@
                       <a:endParaRPr lang="en-US" sz="1400" dirty="0"/>
                     </a:p>
                   </a:txBody>
-                  <a:tcPr marL="91440" marR="91440" marT="45720" marB="45720" anchor="ctr">
+                  <a:tcPr anchor="ctr">
                     <a:lnL w="12700" cap="flat" cmpd="sng" algn="ctr">
                       <a:solidFill>
                         <a:srgbClr val="E2E8F0"/>
@@ -8507,7 +8371,7 @@
                     <a:bodyPr/>
                     <a:lstStyle/>
                     <a:p>
-                      <a:pPr algn="l" indent="0" marL="0">
+                      <a:pPr marL="0" indent="0" algn="l">
                         <a:buNone/>
                       </a:pPr>
                       <a:r>
@@ -8521,7 +8385,7 @@
                       <a:endParaRPr lang="en-US" sz="1400" dirty="0"/>
                     </a:p>
                   </a:txBody>
-                  <a:tcPr marL="91440" marR="91440" marT="45720" marB="45720" anchor="ctr">
+                  <a:tcPr anchor="ctr">
                     <a:lnL w="12700" cap="flat" cmpd="sng" algn="ctr">
                       <a:solidFill>
                         <a:srgbClr val="E2E8F0"/>
@@ -8563,6 +8427,11 @@
                     </a:solidFill>
                   </a:tcPr>
                 </a:tc>
+                <a:extLst>
+                  <a:ext uri="{0D108BD9-81ED-4DB2-BD59-A6C34878D82A}">
+                    <a16:rowId xmlns:a16="http://schemas.microsoft.com/office/drawing/2014/main" val="10000"/>
+                  </a:ext>
+                </a:extLst>
               </a:tr>
               <a:tr h="533400">
                 <a:tc>
@@ -8570,7 +8439,7 @@
                     <a:bodyPr/>
                     <a:lstStyle/>
                     <a:p>
-                      <a:pPr algn="l" indent="0" marL="0">
+                      <a:pPr marL="0" indent="0" algn="l">
                         <a:buNone/>
                       </a:pPr>
                       <a:r>
@@ -8584,7 +8453,7 @@
                       <a:endParaRPr lang="en-US" sz="1400" dirty="0"/>
                     </a:p>
                   </a:txBody>
-                  <a:tcPr marL="91440" marR="91440" marT="45720" marB="45720" anchor="ctr">
+                  <a:tcPr anchor="ctr">
                     <a:lnL w="12700" cap="flat" cmpd="sng" algn="ctr">
                       <a:solidFill>
                         <a:srgbClr val="E2E8F0"/>
@@ -8631,7 +8500,7 @@
                     <a:bodyPr/>
                     <a:lstStyle/>
                     <a:p>
-                      <a:pPr algn="l" indent="0" marL="0">
+                      <a:pPr marL="0" indent="0" algn="l">
                         <a:buNone/>
                       </a:pPr>
                       <a:r>
@@ -8645,7 +8514,7 @@
                       <a:endParaRPr lang="en-US" sz="1400" dirty="0"/>
                     </a:p>
                   </a:txBody>
-                  <a:tcPr marL="91440" marR="91440" marT="45720" marB="45720" anchor="ctr">
+                  <a:tcPr anchor="ctr">
                     <a:lnL w="12700" cap="flat" cmpd="sng" algn="ctr">
                       <a:solidFill>
                         <a:srgbClr val="E2E8F0"/>
@@ -8692,7 +8561,7 @@
                     <a:bodyPr/>
                     <a:lstStyle/>
                     <a:p>
-                      <a:pPr algn="l" indent="0" marL="0">
+                      <a:pPr marL="0" indent="0" algn="l">
                         <a:buNone/>
                       </a:pPr>
                       <a:r>
@@ -8706,7 +8575,7 @@
                       <a:endParaRPr lang="en-US" sz="1400" dirty="0"/>
                     </a:p>
                   </a:txBody>
-                  <a:tcPr marL="91440" marR="91440" marT="45720" marB="45720" anchor="ctr">
+                  <a:tcPr anchor="ctr">
                     <a:lnL w="12700" cap="flat" cmpd="sng" algn="ctr">
                       <a:solidFill>
                         <a:srgbClr val="E2E8F0"/>
@@ -8748,6 +8617,11 @@
                     </a:solidFill>
                   </a:tcPr>
                 </a:tc>
+                <a:extLst>
+                  <a:ext uri="{0D108BD9-81ED-4DB2-BD59-A6C34878D82A}">
+                    <a16:rowId xmlns:a16="http://schemas.microsoft.com/office/drawing/2014/main" val="10001"/>
+                  </a:ext>
+                </a:extLst>
               </a:tr>
               <a:tr h="533400">
                 <a:tc>
@@ -8755,7 +8629,7 @@
                     <a:bodyPr/>
                     <a:lstStyle/>
                     <a:p>
-                      <a:pPr algn="l" indent="0" marL="0">
+                      <a:pPr marL="0" indent="0" algn="l">
                         <a:buNone/>
                       </a:pPr>
                       <a:r>
@@ -8769,7 +8643,7 @@
                       <a:endParaRPr lang="en-US" sz="1400" dirty="0"/>
                     </a:p>
                   </a:txBody>
-                  <a:tcPr marL="91440" marR="91440" marT="45720" marB="45720" anchor="ctr">
+                  <a:tcPr anchor="ctr">
                     <a:lnL w="12700" cap="flat" cmpd="sng" algn="ctr">
                       <a:solidFill>
                         <a:srgbClr val="E2E8F0"/>
@@ -8816,7 +8690,7 @@
                     <a:bodyPr/>
                     <a:lstStyle/>
                     <a:p>
-                      <a:pPr algn="l" indent="0" marL="0">
+                      <a:pPr marL="0" indent="0" algn="l">
                         <a:buNone/>
                       </a:pPr>
                       <a:r>
@@ -8830,7 +8704,7 @@
                       <a:endParaRPr lang="en-US" sz="1400" dirty="0"/>
                     </a:p>
                   </a:txBody>
-                  <a:tcPr marL="91440" marR="91440" marT="45720" marB="45720" anchor="ctr">
+                  <a:tcPr anchor="ctr">
                     <a:lnL w="12700" cap="flat" cmpd="sng" algn="ctr">
                       <a:solidFill>
                         <a:srgbClr val="E2E8F0"/>
@@ -8877,7 +8751,7 @@
                     <a:bodyPr/>
                     <a:lstStyle/>
                     <a:p>
-                      <a:pPr algn="l" indent="0" marL="0">
+                      <a:pPr marL="0" indent="0" algn="l">
                         <a:buNone/>
                       </a:pPr>
                       <a:r>
@@ -8891,7 +8765,7 @@
                       <a:endParaRPr lang="en-US" sz="1400" dirty="0"/>
                     </a:p>
                   </a:txBody>
-                  <a:tcPr marL="91440" marR="91440" marT="45720" marB="45720" anchor="ctr">
+                  <a:tcPr anchor="ctr">
                     <a:lnL w="12700" cap="flat" cmpd="sng" algn="ctr">
                       <a:solidFill>
                         <a:srgbClr val="E2E8F0"/>
@@ -8933,6 +8807,11 @@
                     </a:solidFill>
                   </a:tcPr>
                 </a:tc>
+                <a:extLst>
+                  <a:ext uri="{0D108BD9-81ED-4DB2-BD59-A6C34878D82A}">
+                    <a16:rowId xmlns:a16="http://schemas.microsoft.com/office/drawing/2014/main" val="10002"/>
+                  </a:ext>
+                </a:extLst>
               </a:tr>
               <a:tr h="533400">
                 <a:tc>
@@ -8940,7 +8819,7 @@
                     <a:bodyPr/>
                     <a:lstStyle/>
                     <a:p>
-                      <a:pPr algn="l" indent="0" marL="0">
+                      <a:pPr marL="0" indent="0" algn="l">
                         <a:buNone/>
                       </a:pPr>
                       <a:r>
@@ -8954,7 +8833,7 @@
                       <a:endParaRPr lang="en-US" sz="1400" dirty="0"/>
                     </a:p>
                   </a:txBody>
-                  <a:tcPr marL="91440" marR="91440" marT="45720" marB="45720" anchor="ctr">
+                  <a:tcPr anchor="ctr">
                     <a:lnL w="12700" cap="flat" cmpd="sng" algn="ctr">
                       <a:solidFill>
                         <a:srgbClr val="E2E8F0"/>
@@ -9001,7 +8880,7 @@
                     <a:bodyPr/>
                     <a:lstStyle/>
                     <a:p>
-                      <a:pPr algn="l" indent="0" marL="0">
+                      <a:pPr marL="0" indent="0" algn="l">
                         <a:buNone/>
                       </a:pPr>
                       <a:r>
@@ -9015,7 +8894,7 @@
                       <a:endParaRPr lang="en-US" sz="1400" dirty="0"/>
                     </a:p>
                   </a:txBody>
-                  <a:tcPr marL="91440" marR="91440" marT="45720" marB="45720" anchor="ctr">
+                  <a:tcPr anchor="ctr">
                     <a:lnL w="12700" cap="flat" cmpd="sng" algn="ctr">
                       <a:solidFill>
                         <a:srgbClr val="E2E8F0"/>
@@ -9062,7 +8941,7 @@
                     <a:bodyPr/>
                     <a:lstStyle/>
                     <a:p>
-                      <a:pPr algn="l" indent="0" marL="0">
+                      <a:pPr marL="0" indent="0" algn="l">
                         <a:buNone/>
                       </a:pPr>
                       <a:r>
@@ -9076,7 +8955,7 @@
                       <a:endParaRPr lang="en-US" sz="1400" dirty="0"/>
                     </a:p>
                   </a:txBody>
-                  <a:tcPr marL="91440" marR="91440" marT="45720" marB="45720" anchor="ctr">
+                  <a:tcPr anchor="ctr">
                     <a:lnL w="12700" cap="flat" cmpd="sng" algn="ctr">
                       <a:solidFill>
                         <a:srgbClr val="E2E8F0"/>
@@ -9118,6 +8997,11 @@
                     </a:solidFill>
                   </a:tcPr>
                 </a:tc>
+                <a:extLst>
+                  <a:ext uri="{0D108BD9-81ED-4DB2-BD59-A6C34878D82A}">
+                    <a16:rowId xmlns:a16="http://schemas.microsoft.com/office/drawing/2014/main" val="10003"/>
+                  </a:ext>
+                </a:extLst>
               </a:tr>
               <a:tr h="533400">
                 <a:tc>
@@ -9125,7 +9009,7 @@
                     <a:bodyPr/>
                     <a:lstStyle/>
                     <a:p>
-                      <a:pPr algn="l" indent="0" marL="0">
+                      <a:pPr marL="0" indent="0" algn="l">
                         <a:buNone/>
                       </a:pPr>
                       <a:r>
@@ -9139,7 +9023,7 @@
                       <a:endParaRPr lang="en-US" sz="1400" dirty="0"/>
                     </a:p>
                   </a:txBody>
-                  <a:tcPr marL="91440" marR="91440" marT="45720" marB="45720" anchor="ctr">
+                  <a:tcPr anchor="ctr">
                     <a:lnL w="12700" cap="flat" cmpd="sng" algn="ctr">
                       <a:solidFill>
                         <a:srgbClr val="E2E8F0"/>
@@ -9186,7 +9070,7 @@
                     <a:bodyPr/>
                     <a:lstStyle/>
                     <a:p>
-                      <a:pPr algn="l" indent="0" marL="0">
+                      <a:pPr marL="0" indent="0" algn="l">
                         <a:buNone/>
                       </a:pPr>
                       <a:r>
@@ -9200,7 +9084,7 @@
                       <a:endParaRPr lang="en-US" sz="1400" dirty="0"/>
                     </a:p>
                   </a:txBody>
-                  <a:tcPr marL="91440" marR="91440" marT="45720" marB="45720" anchor="ctr">
+                  <a:tcPr anchor="ctr">
                     <a:lnL w="12700" cap="flat" cmpd="sng" algn="ctr">
                       <a:solidFill>
                         <a:srgbClr val="E2E8F0"/>
@@ -9247,7 +9131,7 @@
                     <a:bodyPr/>
                     <a:lstStyle/>
                     <a:p>
-                      <a:pPr algn="l" indent="0" marL="0">
+                      <a:pPr marL="0" indent="0" algn="l">
                         <a:buNone/>
                       </a:pPr>
                       <a:r>
@@ -9261,7 +9145,7 @@
                       <a:endParaRPr lang="en-US" sz="1400" dirty="0"/>
                     </a:p>
                   </a:txBody>
-                  <a:tcPr marL="91440" marR="91440" marT="45720" marB="45720" anchor="ctr">
+                  <a:tcPr anchor="ctr">
                     <a:lnL w="12700" cap="flat" cmpd="sng" algn="ctr">
                       <a:solidFill>
                         <a:srgbClr val="E2E8F0"/>
@@ -9303,6 +9187,11 @@
                     </a:solidFill>
                   </a:tcPr>
                 </a:tc>
+                <a:extLst>
+                  <a:ext uri="{0D108BD9-81ED-4DB2-BD59-A6C34878D82A}">
+                    <a16:rowId xmlns:a16="http://schemas.microsoft.com/office/drawing/2014/main" val="10004"/>
+                  </a:ext>
+                </a:extLst>
               </a:tr>
               <a:tr h="533400">
                 <a:tc>
@@ -9310,7 +9199,7 @@
                     <a:bodyPr/>
                     <a:lstStyle/>
                     <a:p>
-                      <a:pPr algn="l" indent="0" marL="0">
+                      <a:pPr marL="0" indent="0" algn="l">
                         <a:buNone/>
                       </a:pPr>
                       <a:r>
@@ -9324,7 +9213,7 @@
                       <a:endParaRPr lang="en-US" sz="1400" dirty="0"/>
                     </a:p>
                   </a:txBody>
-                  <a:tcPr marL="91440" marR="91440" marT="45720" marB="45720" anchor="ctr">
+                  <a:tcPr anchor="ctr">
                     <a:lnL w="12700" cap="flat" cmpd="sng" algn="ctr">
                       <a:solidFill>
                         <a:srgbClr val="E2E8F0"/>
@@ -9371,7 +9260,7 @@
                     <a:bodyPr/>
                     <a:lstStyle/>
                     <a:p>
-                      <a:pPr algn="l" indent="0" marL="0">
+                      <a:pPr marL="0" indent="0" algn="l">
                         <a:buNone/>
                       </a:pPr>
                       <a:r>
@@ -9385,7 +9274,7 @@
                       <a:endParaRPr lang="en-US" sz="1400" dirty="0"/>
                     </a:p>
                   </a:txBody>
-                  <a:tcPr marL="91440" marR="91440" marT="45720" marB="45720" anchor="ctr">
+                  <a:tcPr anchor="ctr">
                     <a:lnL w="12700" cap="flat" cmpd="sng" algn="ctr">
                       <a:solidFill>
                         <a:srgbClr val="E2E8F0"/>
@@ -9432,7 +9321,7 @@
                     <a:bodyPr/>
                     <a:lstStyle/>
                     <a:p>
-                      <a:pPr algn="l" indent="0" marL="0">
+                      <a:pPr marL="0" indent="0" algn="l">
                         <a:buNone/>
                       </a:pPr>
                       <a:r>
@@ -9446,7 +9335,7 @@
                       <a:endParaRPr lang="en-US" sz="1400" dirty="0"/>
                     </a:p>
                   </a:txBody>
-                  <a:tcPr marL="91440" marR="91440" marT="45720" marB="45720" anchor="ctr">
+                  <a:tcPr anchor="ctr">
                     <a:lnL w="12700" cap="flat" cmpd="sng" algn="ctr">
                       <a:solidFill>
                         <a:srgbClr val="E2E8F0"/>
@@ -9488,6 +9377,11 @@
                     </a:solidFill>
                   </a:tcPr>
                 </a:tc>
+                <a:extLst>
+                  <a:ext uri="{0D108BD9-81ED-4DB2-BD59-A6C34878D82A}">
+                    <a16:rowId xmlns:a16="http://schemas.microsoft.com/office/drawing/2014/main" val="10005"/>
+                  </a:ext>
+                </a:extLst>
               </a:tr>
             </a:tbl>
           </a:graphicData>
@@ -9509,6 +9403,7 @@
         <a:solidFill>
           <a:srgbClr val="FFFFFF"/>
         </a:solidFill>
+        <a:effectLst/>
       </p:bgPr>
     </p:bg>
     <p:spTree>
@@ -9546,7 +9441,7 @@
           <a:bodyPr wrap="square" lIns="0" tIns="0" rIns="0" bIns="0" rtlCol="0" anchor="ctr"/>
           <a:lstStyle/>
           <a:p>
-            <a:pPr indent="0" marL="0">
+            <a:pPr marL="0" indent="0">
               <a:buNone/>
             </a:pPr>
             <a:r>
@@ -9588,7 +9483,7 @@
             <a:prstDash val="solid"/>
           </a:ln>
           <a:effectLst>
-            <a:outerShdw sx="100000" sy="100000" kx="0" ky="0" algn="bl" rotWithShape="0" blurRad="76200" dist="25400" dir="8100000">
+            <a:outerShdw blurRad="76200" dist="25400" dir="8100000" algn="bl" rotWithShape="0">
               <a:srgbClr val="000000">
                 <a:alpha val="12000"/>
               </a:srgbClr>
@@ -9617,7 +9512,7 @@
           <a:bodyPr wrap="square" lIns="0" tIns="0" rIns="0" bIns="0" rtlCol="0" anchor="ctr"/>
           <a:lstStyle/>
           <a:p>
-            <a:pPr algn="ctr" indent="0" marL="0">
+            <a:pPr marL="0" indent="0" algn="ctr">
               <a:buNone/>
             </a:pPr>
             <a:r>
@@ -9656,7 +9551,7 @@
           <a:bodyPr wrap="square" lIns="0" tIns="0" rIns="0" bIns="0" rtlCol="0" anchor="ctr"/>
           <a:lstStyle/>
           <a:p>
-            <a:pPr algn="ctr" indent="0" marL="0">
+            <a:pPr marL="0" indent="0" algn="ctr">
               <a:buNone/>
             </a:pPr>
             <a:r>
@@ -9698,7 +9593,7 @@
             <a:prstDash val="solid"/>
           </a:ln>
           <a:effectLst>
-            <a:outerShdw sx="100000" sy="100000" kx="0" ky="0" algn="bl" rotWithShape="0" blurRad="76200" dist="25400" dir="8100000">
+            <a:outerShdw blurRad="76200" dist="25400" dir="8100000" algn="bl" rotWithShape="0">
               <a:srgbClr val="000000">
                 <a:alpha val="12000"/>
               </a:srgbClr>
@@ -9727,7 +9622,7 @@
           <a:bodyPr wrap="square" lIns="0" tIns="0" rIns="0" bIns="0" rtlCol="0" anchor="ctr"/>
           <a:lstStyle/>
           <a:p>
-            <a:pPr algn="ctr" indent="0" marL="0">
+            <a:pPr marL="0" indent="0" algn="ctr">
               <a:buNone/>
             </a:pPr>
             <a:r>
@@ -9766,7 +9661,7 @@
           <a:bodyPr wrap="square" lIns="0" tIns="0" rIns="0" bIns="0" rtlCol="0" anchor="ctr"/>
           <a:lstStyle/>
           <a:p>
-            <a:pPr algn="ctr" indent="0" marL="0">
+            <a:pPr marL="0" indent="0" algn="ctr">
               <a:buNone/>
             </a:pPr>
             <a:r>
@@ -9808,7 +9703,7 @@
             <a:prstDash val="solid"/>
           </a:ln>
           <a:effectLst>
-            <a:outerShdw sx="100000" sy="100000" kx="0" ky="0" algn="bl" rotWithShape="0" blurRad="76200" dist="25400" dir="8100000">
+            <a:outerShdw blurRad="76200" dist="25400" dir="8100000" algn="bl" rotWithShape="0">
               <a:srgbClr val="000000">
                 <a:alpha val="12000"/>
               </a:srgbClr>
@@ -9837,7 +9732,7 @@
           <a:bodyPr wrap="square" lIns="0" tIns="0" rIns="0" bIns="0" rtlCol="0" anchor="ctr"/>
           <a:lstStyle/>
           <a:p>
-            <a:pPr algn="ctr" indent="0" marL="0">
+            <a:pPr marL="0" indent="0" algn="ctr">
               <a:buNone/>
             </a:pPr>
             <a:r>
@@ -9876,7 +9771,7 @@
           <a:bodyPr wrap="square" lIns="0" tIns="0" rIns="0" bIns="0" rtlCol="0" anchor="ctr"/>
           <a:lstStyle/>
           <a:p>
-            <a:pPr algn="ctr" indent="0" marL="0">
+            <a:pPr marL="0" indent="0" algn="ctr">
               <a:buNone/>
             </a:pPr>
             <a:r>
@@ -9940,7 +9835,7 @@
           <a:bodyPr wrap="square" lIns="0" tIns="0" rIns="0" bIns="0" rtlCol="0" anchor="ctr"/>
           <a:lstStyle/>
           <a:p>
-            <a:pPr algn="l" indent="0" marL="0">
+            <a:pPr marL="0" indent="0" algn="l">
               <a:buNone/>
             </a:pPr>
             <a:r>
@@ -9960,7 +9855,7 @@
       </p:sp>
       <p:graphicFrame>
         <p:nvGraphicFramePr>
-          <p:cNvPr id="7" name="Table 0"/>
+          <p:cNvPr id="14" name="Table 0"/>
           <p:cNvGraphicFramePr>
             <a:graphicFrameLocks noGrp="1"/>
           </p:cNvGraphicFramePr>
@@ -9981,9 +9876,27 @@
             <a:tbl>
               <a:tblPr/>
               <a:tblGrid>
-                <a:gridCol w="4114800"/>
-                <a:gridCol w="2286000"/>
-                <a:gridCol w="1828800"/>
+                <a:gridCol w="4114800">
+                  <a:extLst>
+                    <a:ext uri="{9D8B030D-6E8A-4147-A177-3AD203B41FA5}">
+                      <a16:colId xmlns:a16="http://schemas.microsoft.com/office/drawing/2014/main" val="20000"/>
+                    </a:ext>
+                  </a:extLst>
+                </a:gridCol>
+                <a:gridCol w="2286000">
+                  <a:extLst>
+                    <a:ext uri="{9D8B030D-6E8A-4147-A177-3AD203B41FA5}">
+                      <a16:colId xmlns:a16="http://schemas.microsoft.com/office/drawing/2014/main" val="20001"/>
+                    </a:ext>
+                  </a:extLst>
+                </a:gridCol>
+                <a:gridCol w="1828800">
+                  <a:extLst>
+                    <a:ext uri="{9D8B030D-6E8A-4147-A177-3AD203B41FA5}">
+                      <a16:colId xmlns:a16="http://schemas.microsoft.com/office/drawing/2014/main" val="20002"/>
+                    </a:ext>
+                  </a:extLst>
+                </a:gridCol>
               </a:tblGrid>
               <a:tr h="365760">
                 <a:tc>
@@ -9991,7 +9904,7 @@
                     <a:bodyPr/>
                     <a:lstStyle/>
                     <a:p>
-                      <a:pPr algn="l" indent="0" marL="0">
+                      <a:pPr marL="0" indent="0" algn="l">
                         <a:buNone/>
                       </a:pPr>
                       <a:r>
@@ -10005,7 +9918,7 @@
                       <a:endParaRPr lang="en-US" sz="1200" dirty="0"/>
                     </a:p>
                   </a:txBody>
-                  <a:tcPr marL="91440" marR="91440" marT="45720" marB="45720" anchor="ctr">
+                  <a:tcPr anchor="ctr">
                     <a:lnL w="12700" cap="flat" cmpd="sng" algn="ctr">
                       <a:solidFill>
                         <a:srgbClr val="E2E8F0"/>
@@ -10052,7 +9965,7 @@
                     <a:bodyPr/>
                     <a:lstStyle/>
                     <a:p>
-                      <a:pPr algn="l" indent="0" marL="0">
+                      <a:pPr marL="0" indent="0" algn="l">
                         <a:buNone/>
                       </a:pPr>
                       <a:r>
@@ -10066,7 +9979,7 @@
                       <a:endParaRPr lang="en-US" sz="1200" dirty="0"/>
                     </a:p>
                   </a:txBody>
-                  <a:tcPr marL="91440" marR="91440" marT="45720" marB="45720" anchor="ctr">
+                  <a:tcPr anchor="ctr">
                     <a:lnL w="12700" cap="flat" cmpd="sng" algn="ctr">
                       <a:solidFill>
                         <a:srgbClr val="E2E8F0"/>
@@ -10113,7 +10026,7 @@
                     <a:bodyPr/>
                     <a:lstStyle/>
                     <a:p>
-                      <a:pPr algn="l" indent="0" marL="0">
+                      <a:pPr marL="0" indent="0" algn="l">
                         <a:buNone/>
                       </a:pPr>
                       <a:r>
@@ -10127,7 +10040,7 @@
                       <a:endParaRPr lang="en-US" sz="1200" dirty="0"/>
                     </a:p>
                   </a:txBody>
-                  <a:tcPr marL="91440" marR="91440" marT="45720" marB="45720" anchor="ctr">
+                  <a:tcPr anchor="ctr">
                     <a:lnL w="12700" cap="flat" cmpd="sng" algn="ctr">
                       <a:solidFill>
                         <a:srgbClr val="E2E8F0"/>
@@ -10169,6 +10082,11 @@
                     </a:solidFill>
                   </a:tcPr>
                 </a:tc>
+                <a:extLst>
+                  <a:ext uri="{0D108BD9-81ED-4DB2-BD59-A6C34878D82A}">
+                    <a16:rowId xmlns:a16="http://schemas.microsoft.com/office/drawing/2014/main" val="10000"/>
+                  </a:ext>
+                </a:extLst>
               </a:tr>
               <a:tr h="365760">
                 <a:tc>
@@ -10176,7 +10094,7 @@
                     <a:bodyPr/>
                     <a:lstStyle/>
                     <a:p>
-                      <a:pPr algn="l" indent="0" marL="0">
+                      <a:pPr marL="0" indent="0" algn="l">
                         <a:buNone/>
                       </a:pPr>
                       <a:r>
@@ -10190,7 +10108,7 @@
                       <a:endParaRPr lang="en-US" sz="1200" dirty="0"/>
                     </a:p>
                   </a:txBody>
-                  <a:tcPr marL="91440" marR="91440" marT="45720" marB="45720" anchor="ctr">
+                  <a:tcPr anchor="ctr">
                     <a:lnL w="12700" cap="flat" cmpd="sng" algn="ctr">
                       <a:solidFill>
                         <a:srgbClr val="E2E8F0"/>
@@ -10237,7 +10155,7 @@
                     <a:bodyPr/>
                     <a:lstStyle/>
                     <a:p>
-                      <a:pPr algn="l" indent="0" marL="0">
+                      <a:pPr marL="0" indent="0" algn="l">
                         <a:buNone/>
                       </a:pPr>
                       <a:r>
@@ -10251,7 +10169,7 @@
                       <a:endParaRPr lang="en-US" sz="1200" dirty="0"/>
                     </a:p>
                   </a:txBody>
-                  <a:tcPr marL="91440" marR="91440" marT="45720" marB="45720" anchor="ctr">
+                  <a:tcPr anchor="ctr">
                     <a:lnL w="12700" cap="flat" cmpd="sng" algn="ctr">
                       <a:solidFill>
                         <a:srgbClr val="E2E8F0"/>
@@ -10298,7 +10216,7 @@
                     <a:bodyPr/>
                     <a:lstStyle/>
                     <a:p>
-                      <a:pPr algn="l" indent="0" marL="0">
+                      <a:pPr marL="0" indent="0" algn="l">
                         <a:buNone/>
                       </a:pPr>
                       <a:r>
@@ -10312,7 +10230,7 @@
                       <a:endParaRPr lang="en-US" sz="1200" dirty="0"/>
                     </a:p>
                   </a:txBody>
-                  <a:tcPr marL="91440" marR="91440" marT="45720" marB="45720" anchor="ctr">
+                  <a:tcPr anchor="ctr">
                     <a:lnL w="12700" cap="flat" cmpd="sng" algn="ctr">
                       <a:solidFill>
                         <a:srgbClr val="E2E8F0"/>
@@ -10354,6 +10272,11 @@
                     </a:solidFill>
                   </a:tcPr>
                 </a:tc>
+                <a:extLst>
+                  <a:ext uri="{0D108BD9-81ED-4DB2-BD59-A6C34878D82A}">
+                    <a16:rowId xmlns:a16="http://schemas.microsoft.com/office/drawing/2014/main" val="10001"/>
+                  </a:ext>
+                </a:extLst>
               </a:tr>
               <a:tr h="365760">
                 <a:tc>
@@ -10361,7 +10284,7 @@
                     <a:bodyPr/>
                     <a:lstStyle/>
                     <a:p>
-                      <a:pPr algn="l" indent="0" marL="0">
+                      <a:pPr marL="0" indent="0" algn="l">
                         <a:buNone/>
                       </a:pPr>
                       <a:r>
@@ -10375,7 +10298,7 @@
                       <a:endParaRPr lang="en-US" sz="1200" dirty="0"/>
                     </a:p>
                   </a:txBody>
-                  <a:tcPr marL="91440" marR="91440" marT="45720" marB="45720" anchor="ctr">
+                  <a:tcPr anchor="ctr">
                     <a:lnL w="12700" cap="flat" cmpd="sng" algn="ctr">
                       <a:solidFill>
                         <a:srgbClr val="E2E8F0"/>
@@ -10422,7 +10345,7 @@
                     <a:bodyPr/>
                     <a:lstStyle/>
                     <a:p>
-                      <a:pPr algn="l" indent="0" marL="0">
+                      <a:pPr marL="0" indent="0" algn="l">
                         <a:buNone/>
                       </a:pPr>
                       <a:r>
@@ -10436,7 +10359,7 @@
                       <a:endParaRPr lang="en-US" sz="1200" dirty="0"/>
                     </a:p>
                   </a:txBody>
-                  <a:tcPr marL="91440" marR="91440" marT="45720" marB="45720" anchor="ctr">
+                  <a:tcPr anchor="ctr">
                     <a:lnL w="12700" cap="flat" cmpd="sng" algn="ctr">
                       <a:solidFill>
                         <a:srgbClr val="E2E8F0"/>
@@ -10483,7 +10406,7 @@
                     <a:bodyPr/>
                     <a:lstStyle/>
                     <a:p>
-                      <a:pPr algn="l" indent="0" marL="0">
+                      <a:pPr marL="0" indent="0" algn="l">
                         <a:buNone/>
                       </a:pPr>
                       <a:r>
@@ -10497,7 +10420,7 @@
                       <a:endParaRPr lang="en-US" sz="1200" dirty="0"/>
                     </a:p>
                   </a:txBody>
-                  <a:tcPr marL="91440" marR="91440" marT="45720" marB="45720" anchor="ctr">
+                  <a:tcPr anchor="ctr">
                     <a:lnL w="12700" cap="flat" cmpd="sng" algn="ctr">
                       <a:solidFill>
                         <a:srgbClr val="E2E8F0"/>
@@ -10539,6 +10462,11 @@
                     </a:solidFill>
                   </a:tcPr>
                 </a:tc>
+                <a:extLst>
+                  <a:ext uri="{0D108BD9-81ED-4DB2-BD59-A6C34878D82A}">
+                    <a16:rowId xmlns:a16="http://schemas.microsoft.com/office/drawing/2014/main" val="10002"/>
+                  </a:ext>
+                </a:extLst>
               </a:tr>
               <a:tr h="365760">
                 <a:tc>
@@ -10546,7 +10474,7 @@
                     <a:bodyPr/>
                     <a:lstStyle/>
                     <a:p>
-                      <a:pPr algn="l" indent="0" marL="0">
+                      <a:pPr marL="0" indent="0" algn="l">
                         <a:buNone/>
                       </a:pPr>
                       <a:r>
@@ -10560,7 +10488,7 @@
                       <a:endParaRPr lang="en-US" sz="1200" dirty="0"/>
                     </a:p>
                   </a:txBody>
-                  <a:tcPr marL="91440" marR="91440" marT="45720" marB="45720" anchor="ctr">
+                  <a:tcPr anchor="ctr">
                     <a:lnL w="12700" cap="flat" cmpd="sng" algn="ctr">
                       <a:solidFill>
                         <a:srgbClr val="E2E8F0"/>
@@ -10607,7 +10535,7 @@
                     <a:bodyPr/>
                     <a:lstStyle/>
                     <a:p>
-                      <a:pPr algn="l" indent="0" marL="0">
+                      <a:pPr marL="0" indent="0" algn="l">
                         <a:buNone/>
                       </a:pPr>
                       <a:r>
@@ -10621,7 +10549,7 @@
                       <a:endParaRPr lang="en-US" sz="1200" dirty="0"/>
                     </a:p>
                   </a:txBody>
-                  <a:tcPr marL="91440" marR="91440" marT="45720" marB="45720" anchor="ctr">
+                  <a:tcPr anchor="ctr">
                     <a:lnL w="12700" cap="flat" cmpd="sng" algn="ctr">
                       <a:solidFill>
                         <a:srgbClr val="E2E8F0"/>
@@ -10668,7 +10596,7 @@
                     <a:bodyPr/>
                     <a:lstStyle/>
                     <a:p>
-                      <a:pPr algn="l" indent="0" marL="0">
+                      <a:pPr marL="0" indent="0" algn="l">
                         <a:buNone/>
                       </a:pPr>
                       <a:r>
@@ -10682,7 +10610,7 @@
                       <a:endParaRPr lang="en-US" sz="1200" dirty="0"/>
                     </a:p>
                   </a:txBody>
-                  <a:tcPr marL="91440" marR="91440" marT="45720" marB="45720" anchor="ctr">
+                  <a:tcPr anchor="ctr">
                     <a:lnL w="12700" cap="flat" cmpd="sng" algn="ctr">
                       <a:solidFill>
                         <a:srgbClr val="E2E8F0"/>
@@ -10724,6 +10652,11 @@
                     </a:solidFill>
                   </a:tcPr>
                 </a:tc>
+                <a:extLst>
+                  <a:ext uri="{0D108BD9-81ED-4DB2-BD59-A6C34878D82A}">
+                    <a16:rowId xmlns:a16="http://schemas.microsoft.com/office/drawing/2014/main" val="10003"/>
+                  </a:ext>
+                </a:extLst>
               </a:tr>
               <a:tr h="365760">
                 <a:tc>
@@ -10731,7 +10664,7 @@
                     <a:bodyPr/>
                     <a:lstStyle/>
                     <a:p>
-                      <a:pPr algn="l" indent="0" marL="0">
+                      <a:pPr marL="0" indent="0" algn="l">
                         <a:buNone/>
                       </a:pPr>
                       <a:r>
@@ -10745,7 +10678,7 @@
                       <a:endParaRPr lang="en-US" sz="1200" dirty="0"/>
                     </a:p>
                   </a:txBody>
-                  <a:tcPr marL="91440" marR="91440" marT="45720" marB="45720" anchor="ctr">
+                  <a:tcPr anchor="ctr">
                     <a:lnL w="12700" cap="flat" cmpd="sng" algn="ctr">
                       <a:solidFill>
                         <a:srgbClr val="E2E8F0"/>
@@ -10792,7 +10725,7 @@
                     <a:bodyPr/>
                     <a:lstStyle/>
                     <a:p>
-                      <a:pPr algn="l" indent="0" marL="0">
+                      <a:pPr marL="0" indent="0" algn="l">
                         <a:buNone/>
                       </a:pPr>
                       <a:r>
@@ -10806,7 +10739,7 @@
                       <a:endParaRPr lang="en-US" sz="1200" dirty="0"/>
                     </a:p>
                   </a:txBody>
-                  <a:tcPr marL="91440" marR="91440" marT="45720" marB="45720" anchor="ctr">
+                  <a:tcPr anchor="ctr">
                     <a:lnL w="12700" cap="flat" cmpd="sng" algn="ctr">
                       <a:solidFill>
                         <a:srgbClr val="E2E8F0"/>
@@ -10853,7 +10786,7 @@
                     <a:bodyPr/>
                     <a:lstStyle/>
                     <a:p>
-                      <a:pPr algn="l" indent="0" marL="0">
+                      <a:pPr marL="0" indent="0" algn="l">
                         <a:buNone/>
                       </a:pPr>
                       <a:r>
@@ -10867,7 +10800,7 @@
                       <a:endParaRPr lang="en-US" sz="1200" dirty="0"/>
                     </a:p>
                   </a:txBody>
-                  <a:tcPr marL="91440" marR="91440" marT="45720" marB="45720" anchor="ctr">
+                  <a:tcPr anchor="ctr">
                     <a:lnL w="12700" cap="flat" cmpd="sng" algn="ctr">
                       <a:solidFill>
                         <a:srgbClr val="E2E8F0"/>
@@ -10909,6 +10842,11 @@
                     </a:solidFill>
                   </a:tcPr>
                 </a:tc>
+                <a:extLst>
+                  <a:ext uri="{0D108BD9-81ED-4DB2-BD59-A6C34878D82A}">
+                    <a16:rowId xmlns:a16="http://schemas.microsoft.com/office/drawing/2014/main" val="10004"/>
+                  </a:ext>
+                </a:extLst>
               </a:tr>
               <a:tr h="365760">
                 <a:tc>
@@ -10916,7 +10854,7 @@
                     <a:bodyPr/>
                     <a:lstStyle/>
                     <a:p>
-                      <a:pPr algn="l" indent="0" marL="0">
+                      <a:pPr marL="0" indent="0" algn="l">
                         <a:buNone/>
                       </a:pPr>
                       <a:r>
@@ -10930,7 +10868,7 @@
                       <a:endParaRPr lang="en-US" sz="1200" dirty="0"/>
                     </a:p>
                   </a:txBody>
-                  <a:tcPr marL="91440" marR="91440" marT="45720" marB="45720" anchor="ctr">
+                  <a:tcPr anchor="ctr">
                     <a:lnL w="12700" cap="flat" cmpd="sng" algn="ctr">
                       <a:solidFill>
                         <a:srgbClr val="E2E8F0"/>
@@ -10977,7 +10915,7 @@
                     <a:bodyPr/>
                     <a:lstStyle/>
                     <a:p>
-                      <a:pPr algn="l" indent="0" marL="0">
+                      <a:pPr marL="0" indent="0" algn="l">
                         <a:buNone/>
                       </a:pPr>
                       <a:r>
@@ -10991,7 +10929,7 @@
                       <a:endParaRPr lang="en-US" sz="1200" dirty="0"/>
                     </a:p>
                   </a:txBody>
-                  <a:tcPr marL="91440" marR="91440" marT="45720" marB="45720" anchor="ctr">
+                  <a:tcPr anchor="ctr">
                     <a:lnL w="12700" cap="flat" cmpd="sng" algn="ctr">
                       <a:solidFill>
                         <a:srgbClr val="E2E8F0"/>
@@ -11038,7 +10976,7 @@
                     <a:bodyPr/>
                     <a:lstStyle/>
                     <a:p>
-                      <a:pPr algn="l" indent="0" marL="0">
+                      <a:pPr marL="0" indent="0" algn="l">
                         <a:buNone/>
                       </a:pPr>
                       <a:r>
@@ -11052,7 +10990,7 @@
                       <a:endParaRPr lang="en-US" sz="1200" dirty="0"/>
                     </a:p>
                   </a:txBody>
-                  <a:tcPr marL="91440" marR="91440" marT="45720" marB="45720" anchor="ctr">
+                  <a:tcPr anchor="ctr">
                     <a:lnL w="12700" cap="flat" cmpd="sng" algn="ctr">
                       <a:solidFill>
                         <a:srgbClr val="E2E8F0"/>
@@ -11094,6 +11032,11 @@
                     </a:solidFill>
                   </a:tcPr>
                 </a:tc>
+                <a:extLst>
+                  <a:ext uri="{0D108BD9-81ED-4DB2-BD59-A6C34878D82A}">
+                    <a16:rowId xmlns:a16="http://schemas.microsoft.com/office/drawing/2014/main" val="10005"/>
+                  </a:ext>
+                </a:extLst>
               </a:tr>
             </a:tbl>
           </a:graphicData>
@@ -11115,6 +11058,7 @@
         <a:solidFill>
           <a:srgbClr val="FFFFFF"/>
         </a:solidFill>
+        <a:effectLst/>
       </p:bgPr>
     </p:bg>
     <p:spTree>
@@ -11152,7 +11096,7 @@
           <a:bodyPr wrap="square" lIns="0" tIns="0" rIns="0" bIns="0" rtlCol="0" anchor="ctr"/>
           <a:lstStyle/>
           <a:p>
-            <a:pPr indent="0" marL="0">
+            <a:pPr marL="0" indent="0">
               <a:buNone/>
             </a:pPr>
             <a:r>
@@ -11191,7 +11135,7 @@
           <a:bodyPr wrap="square" lIns="0" tIns="0" rIns="0" bIns="0" rtlCol="0" anchor="ctr"/>
           <a:lstStyle/>
           <a:p>
-            <a:pPr algn="l" indent="0" marL="0">
+            <a:pPr marL="0" indent="0" algn="l">
               <a:buNone/>
             </a:pPr>
             <a:r>
@@ -11270,7 +11214,7 @@
           <a:bodyPr wrap="square" lIns="0" tIns="0" rIns="0" bIns="0" rtlCol="0" anchor="ctr"/>
           <a:lstStyle/>
           <a:p>
-            <a:pPr algn="r" indent="0" marL="0">
+            <a:pPr marL="0" indent="0" algn="r">
               <a:buNone/>
             </a:pPr>
             <a:r>
@@ -11309,7 +11253,7 @@
           <a:bodyPr wrap="square" lIns="0" tIns="0" rIns="0" bIns="0" rtlCol="0" anchor="ctr"/>
           <a:lstStyle/>
           <a:p>
-            <a:pPr algn="l" indent="0" marL="0">
+            <a:pPr marL="0" indent="0" algn="l">
               <a:buNone/>
             </a:pPr>
             <a:r>
@@ -11388,7 +11332,7 @@
           <a:bodyPr wrap="square" lIns="0" tIns="0" rIns="0" bIns="0" rtlCol="0" anchor="ctr"/>
           <a:lstStyle/>
           <a:p>
-            <a:pPr algn="r" indent="0" marL="0">
+            <a:pPr marL="0" indent="0" algn="r">
               <a:buNone/>
             </a:pPr>
             <a:r>
@@ -11427,7 +11371,7 @@
           <a:bodyPr wrap="square" lIns="0" tIns="0" rIns="0" bIns="0" rtlCol="0" anchor="ctr"/>
           <a:lstStyle/>
           <a:p>
-            <a:pPr algn="l" indent="0" marL="0">
+            <a:pPr marL="0" indent="0" algn="l">
               <a:buNone/>
             </a:pPr>
             <a:r>
@@ -11506,7 +11450,7 @@
           <a:bodyPr wrap="square" lIns="0" tIns="0" rIns="0" bIns="0" rtlCol="0" anchor="ctr"/>
           <a:lstStyle/>
           <a:p>
-            <a:pPr algn="r" indent="0" marL="0">
+            <a:pPr marL="0" indent="0" algn="r">
               <a:buNone/>
             </a:pPr>
             <a:r>
@@ -11545,7 +11489,7 @@
           <a:bodyPr wrap="square" lIns="0" tIns="0" rIns="0" bIns="0" rtlCol="0" anchor="ctr"/>
           <a:lstStyle/>
           <a:p>
-            <a:pPr algn="l" indent="0" marL="0">
+            <a:pPr marL="0" indent="0" algn="l">
               <a:buNone/>
             </a:pPr>
             <a:r>
@@ -11624,7 +11568,7 @@
           <a:bodyPr wrap="square" lIns="0" tIns="0" rIns="0" bIns="0" rtlCol="0" anchor="ctr"/>
           <a:lstStyle/>
           <a:p>
-            <a:pPr algn="r" indent="0" marL="0">
+            <a:pPr marL="0" indent="0" algn="r">
               <a:buNone/>
             </a:pPr>
             <a:r>
@@ -11663,7 +11607,7 @@
           <a:bodyPr wrap="square" lIns="0" tIns="0" rIns="0" bIns="0" rtlCol="0" anchor="ctr"/>
           <a:lstStyle/>
           <a:p>
-            <a:pPr algn="l" indent="0" marL="0">
+            <a:pPr marL="0" indent="0" algn="l">
               <a:buNone/>
             </a:pPr>
             <a:r>
@@ -11742,7 +11686,7 @@
           <a:bodyPr wrap="square" lIns="0" tIns="0" rIns="0" bIns="0" rtlCol="0" anchor="ctr"/>
           <a:lstStyle/>
           <a:p>
-            <a:pPr algn="r" indent="0" marL="0">
+            <a:pPr marL="0" indent="0" algn="r">
               <a:buNone/>
             </a:pPr>
             <a:r>
@@ -11781,7 +11725,7 @@
           <a:bodyPr wrap="square" lIns="0" tIns="0" rIns="0" bIns="0" rtlCol="0" anchor="ctr"/>
           <a:lstStyle/>
           <a:p>
-            <a:pPr algn="l" indent="0" marL="0">
+            <a:pPr marL="0" indent="0" algn="l">
               <a:buNone/>
             </a:pPr>
             <a:r>
@@ -11860,7 +11804,7 @@
           <a:bodyPr wrap="square" lIns="0" tIns="0" rIns="0" bIns="0" rtlCol="0" anchor="ctr"/>
           <a:lstStyle/>
           <a:p>
-            <a:pPr algn="r" indent="0" marL="0">
+            <a:pPr marL="0" indent="0" algn="r">
               <a:buNone/>
             </a:pPr>
             <a:r>
@@ -11899,7 +11843,7 @@
           <a:bodyPr wrap="square" rtlCol="0" anchor="ctr"/>
           <a:lstStyle/>
           <a:p>
-            <a:pPr algn="l" indent="0" marL="0">
+            <a:pPr marL="0" indent="0" algn="l">
               <a:buNone/>
             </a:pPr>
             <a:r>
@@ -11916,7 +11860,7 @@
             <a:endParaRPr lang="en-US" sz="1200" dirty="0"/>
           </a:p>
           <a:p>
-            <a:pPr algn="l" indent="0" marL="0">
+            <a:pPr marL="0" indent="0" algn="l">
               <a:buNone/>
             </a:pPr>
             <a:r>
@@ -11933,7 +11877,7 @@
             <a:endParaRPr lang="en-US" sz="1200" dirty="0"/>
           </a:p>
           <a:p>
-            <a:pPr algn="l" indent="0" marL="0">
+            <a:pPr marL="0" indent="0" algn="l">
               <a:buNone/>
             </a:pPr>
             <a:r>
@@ -11967,6 +11911,7 @@
         <a:solidFill>
           <a:srgbClr val="FFFFFF"/>
         </a:solidFill>
+        <a:effectLst/>
       </p:bgPr>
     </p:bg>
     <p:spTree>
@@ -12004,7 +11949,7 @@
           <a:bodyPr wrap="square" lIns="0" tIns="0" rIns="0" bIns="0" rtlCol="0" anchor="ctr"/>
           <a:lstStyle/>
           <a:p>
-            <a:pPr indent="0" marL="0">
+            <a:pPr marL="0" indent="0">
               <a:buNone/>
             </a:pPr>
             <a:r>
@@ -12046,7 +11991,7 @@
             <a:prstDash val="solid"/>
           </a:ln>
           <a:effectLst>
-            <a:outerShdw sx="100000" sy="100000" kx="0" ky="0" algn="bl" rotWithShape="0" blurRad="76200" dist="25400" dir="8100000">
+            <a:outerShdw blurRad="76200" dist="25400" dir="8100000" algn="bl" rotWithShape="0">
               <a:srgbClr val="000000">
                 <a:alpha val="12000"/>
               </a:srgbClr>
@@ -12075,7 +12020,7 @@
           <a:bodyPr wrap="square" lIns="0" tIns="0" rIns="0" bIns="0" rtlCol="0" anchor="ctr"/>
           <a:lstStyle/>
           <a:p>
-            <a:pPr algn="ctr" indent="0" marL="0">
+            <a:pPr marL="0" indent="0" algn="ctr">
               <a:buNone/>
             </a:pPr>
             <a:r>
@@ -12114,7 +12059,7 @@
           <a:bodyPr wrap="square" lIns="0" tIns="0" rIns="0" bIns="0" rtlCol="0" anchor="ctr"/>
           <a:lstStyle/>
           <a:p>
-            <a:pPr algn="ctr" indent="0" marL="0">
+            <a:pPr marL="0" indent="0" algn="ctr">
               <a:buNone/>
             </a:pPr>
             <a:r>
@@ -12153,7 +12098,7 @@
           <a:bodyPr wrap="square" lIns="0" tIns="0" rIns="0" bIns="0" rtlCol="0" anchor="ctr"/>
           <a:lstStyle/>
           <a:p>
-            <a:pPr algn="ctr" indent="0" marL="0">
+            <a:pPr marL="0" indent="0" algn="ctr">
               <a:buNone/>
             </a:pPr>
             <a:r>
@@ -12195,7 +12140,7 @@
             <a:prstDash val="solid"/>
           </a:ln>
           <a:effectLst>
-            <a:outerShdw sx="100000" sy="100000" kx="0" ky="0" algn="bl" rotWithShape="0" blurRad="76200" dist="25400" dir="8100000">
+            <a:outerShdw blurRad="76200" dist="25400" dir="8100000" algn="bl" rotWithShape="0">
               <a:srgbClr val="000000">
                 <a:alpha val="12000"/>
               </a:srgbClr>
@@ -12224,7 +12169,7 @@
           <a:bodyPr wrap="square" lIns="0" tIns="0" rIns="0" bIns="0" rtlCol="0" anchor="ctr"/>
           <a:lstStyle/>
           <a:p>
-            <a:pPr algn="ctr" indent="0" marL="0">
+            <a:pPr marL="0" indent="0" algn="ctr">
               <a:buNone/>
             </a:pPr>
             <a:r>
@@ -12263,7 +12208,7 @@
           <a:bodyPr wrap="square" lIns="0" tIns="0" rIns="0" bIns="0" rtlCol="0" anchor="ctr"/>
           <a:lstStyle/>
           <a:p>
-            <a:pPr algn="ctr" indent="0" marL="0">
+            <a:pPr marL="0" indent="0" algn="ctr">
               <a:buNone/>
             </a:pPr>
             <a:r>
@@ -12302,7 +12247,7 @@
           <a:bodyPr wrap="square" lIns="0" tIns="0" rIns="0" bIns="0" rtlCol="0" anchor="ctr"/>
           <a:lstStyle/>
           <a:p>
-            <a:pPr algn="ctr" indent="0" marL="0">
+            <a:pPr marL="0" indent="0" algn="ctr">
               <a:buNone/>
             </a:pPr>
             <a:r>
@@ -12344,7 +12289,7 @@
             <a:prstDash val="solid"/>
           </a:ln>
           <a:effectLst>
-            <a:outerShdw sx="100000" sy="100000" kx="0" ky="0" algn="bl" rotWithShape="0" blurRad="76200" dist="25400" dir="8100000">
+            <a:outerShdw blurRad="76200" dist="25400" dir="8100000" algn="bl" rotWithShape="0">
               <a:srgbClr val="000000">
                 <a:alpha val="12000"/>
               </a:srgbClr>
@@ -12373,7 +12318,7 @@
           <a:bodyPr wrap="square" lIns="0" tIns="0" rIns="0" bIns="0" rtlCol="0" anchor="ctr"/>
           <a:lstStyle/>
           <a:p>
-            <a:pPr algn="ctr" indent="0" marL="0">
+            <a:pPr marL="0" indent="0" algn="ctr">
               <a:buNone/>
             </a:pPr>
             <a:r>
@@ -12412,7 +12357,7 @@
           <a:bodyPr wrap="square" lIns="0" tIns="0" rIns="0" bIns="0" rtlCol="0" anchor="ctr"/>
           <a:lstStyle/>
           <a:p>
-            <a:pPr algn="ctr" indent="0" marL="0">
+            <a:pPr marL="0" indent="0" algn="ctr">
               <a:buNone/>
             </a:pPr>
             <a:r>
@@ -12476,7 +12421,7 @@
           <a:bodyPr wrap="square" lIns="0" tIns="0" rIns="0" bIns="0" rtlCol="0" anchor="ctr"/>
           <a:lstStyle/>
           <a:p>
-            <a:pPr algn="l" indent="0" marL="0">
+            <a:pPr marL="0" indent="0" algn="l">
               <a:buNone/>
             </a:pPr>
             <a:r>
@@ -12496,7 +12441,7 @@
       </p:sp>
       <p:graphicFrame>
         <p:nvGraphicFramePr>
-          <p:cNvPr id="9" name="Table 0"/>
+          <p:cNvPr id="16" name="Table 0"/>
           <p:cNvGraphicFramePr>
             <a:graphicFrameLocks noGrp="1"/>
           </p:cNvGraphicFramePr>
@@ -12517,9 +12462,27 @@
             <a:tbl>
               <a:tblPr/>
               <a:tblGrid>
-                <a:gridCol w="2011680"/>
-                <a:gridCol w="1645920"/>
-                <a:gridCol w="914400"/>
+                <a:gridCol w="2011680">
+                  <a:extLst>
+                    <a:ext uri="{9D8B030D-6E8A-4147-A177-3AD203B41FA5}">
+                      <a16:colId xmlns:a16="http://schemas.microsoft.com/office/drawing/2014/main" val="20000"/>
+                    </a:ext>
+                  </a:extLst>
+                </a:gridCol>
+                <a:gridCol w="1645920">
+                  <a:extLst>
+                    <a:ext uri="{9D8B030D-6E8A-4147-A177-3AD203B41FA5}">
+                      <a16:colId xmlns:a16="http://schemas.microsoft.com/office/drawing/2014/main" val="20001"/>
+                    </a:ext>
+                  </a:extLst>
+                </a:gridCol>
+                <a:gridCol w="914400">
+                  <a:extLst>
+                    <a:ext uri="{9D8B030D-6E8A-4147-A177-3AD203B41FA5}">
+                      <a16:colId xmlns:a16="http://schemas.microsoft.com/office/drawing/2014/main" val="20002"/>
+                    </a:ext>
+                  </a:extLst>
+                </a:gridCol>
               </a:tblGrid>
               <a:tr h="304800">
                 <a:tc>
@@ -12527,7 +12490,7 @@
                     <a:bodyPr/>
                     <a:lstStyle/>
                     <a:p>
-                      <a:pPr algn="l" indent="0" marL="0">
+                      <a:pPr marL="0" indent="0" algn="l">
                         <a:buNone/>
                       </a:pPr>
                       <a:r>
@@ -12541,7 +12504,7 @@
                       <a:endParaRPr lang="en-US" sz="1200" dirty="0"/>
                     </a:p>
                   </a:txBody>
-                  <a:tcPr marL="91440" marR="91440" marT="45720" marB="45720" anchor="ctr">
+                  <a:tcPr anchor="ctr">
                     <a:lnL w="12700" cap="flat" cmpd="sng" algn="ctr">
                       <a:solidFill>
                         <a:srgbClr val="E2E8F0"/>
@@ -12588,7 +12551,7 @@
                     <a:bodyPr/>
                     <a:lstStyle/>
                     <a:p>
-                      <a:pPr algn="l" indent="0" marL="0">
+                      <a:pPr marL="0" indent="0" algn="l">
                         <a:buNone/>
                       </a:pPr>
                       <a:r>
@@ -12602,7 +12565,7 @@
                       <a:endParaRPr lang="en-US" sz="1200" dirty="0"/>
                     </a:p>
                   </a:txBody>
-                  <a:tcPr marL="91440" marR="91440" marT="45720" marB="45720" anchor="ctr">
+                  <a:tcPr anchor="ctr">
                     <a:lnL w="12700" cap="flat" cmpd="sng" algn="ctr">
                       <a:solidFill>
                         <a:srgbClr val="E2E8F0"/>
@@ -12649,7 +12612,7 @@
                     <a:bodyPr/>
                     <a:lstStyle/>
                     <a:p>
-                      <a:pPr algn="l" indent="0" marL="0">
+                      <a:pPr marL="0" indent="0" algn="l">
                         <a:buNone/>
                       </a:pPr>
                       <a:r>
@@ -12663,7 +12626,7 @@
                       <a:endParaRPr lang="en-US" sz="1200" dirty="0"/>
                     </a:p>
                   </a:txBody>
-                  <a:tcPr marL="91440" marR="91440" marT="45720" marB="45720" anchor="ctr">
+                  <a:tcPr anchor="ctr">
                     <a:lnL w="12700" cap="flat" cmpd="sng" algn="ctr">
                       <a:solidFill>
                         <a:srgbClr val="E2E8F0"/>
@@ -12705,6 +12668,11 @@
                     </a:solidFill>
                   </a:tcPr>
                 </a:tc>
+                <a:extLst>
+                  <a:ext uri="{0D108BD9-81ED-4DB2-BD59-A6C34878D82A}">
+                    <a16:rowId xmlns:a16="http://schemas.microsoft.com/office/drawing/2014/main" val="10000"/>
+                  </a:ext>
+                </a:extLst>
               </a:tr>
               <a:tr h="304800">
                 <a:tc>
@@ -12712,7 +12680,7 @@
                     <a:bodyPr/>
                     <a:lstStyle/>
                     <a:p>
-                      <a:pPr algn="l" indent="0" marL="0">
+                      <a:pPr marL="0" indent="0" algn="l">
                         <a:buNone/>
                       </a:pPr>
                       <a:r>
@@ -12726,7 +12694,7 @@
                       <a:endParaRPr lang="en-US" sz="1200" dirty="0"/>
                     </a:p>
                   </a:txBody>
-                  <a:tcPr marL="91440" marR="91440" marT="45720" marB="45720" anchor="ctr">
+                  <a:tcPr anchor="ctr">
                     <a:lnL w="12700" cap="flat" cmpd="sng" algn="ctr">
                       <a:solidFill>
                         <a:srgbClr val="E2E8F0"/>
@@ -12773,7 +12741,7 @@
                     <a:bodyPr/>
                     <a:lstStyle/>
                     <a:p>
-                      <a:pPr algn="l" indent="0" marL="0">
+                      <a:pPr marL="0" indent="0" algn="l">
                         <a:buNone/>
                       </a:pPr>
                       <a:r>
@@ -12787,7 +12755,7 @@
                       <a:endParaRPr lang="en-US" sz="1200" dirty="0"/>
                     </a:p>
                   </a:txBody>
-                  <a:tcPr marL="91440" marR="91440" marT="45720" marB="45720" anchor="ctr">
+                  <a:tcPr anchor="ctr">
                     <a:lnL w="12700" cap="flat" cmpd="sng" algn="ctr">
                       <a:solidFill>
                         <a:srgbClr val="E2E8F0"/>
@@ -12834,7 +12802,7 @@
                     <a:bodyPr/>
                     <a:lstStyle/>
                     <a:p>
-                      <a:pPr algn="l" indent="0" marL="0">
+                      <a:pPr marL="0" indent="0" algn="l">
                         <a:buNone/>
                       </a:pPr>
                       <a:r>
@@ -12848,7 +12816,7 @@
                       <a:endParaRPr lang="en-US" sz="1200" dirty="0"/>
                     </a:p>
                   </a:txBody>
-                  <a:tcPr marL="91440" marR="91440" marT="45720" marB="45720" anchor="ctr">
+                  <a:tcPr anchor="ctr">
                     <a:lnL w="12700" cap="flat" cmpd="sng" algn="ctr">
                       <a:solidFill>
                         <a:srgbClr val="E2E8F0"/>
@@ -12890,6 +12858,11 @@
                     </a:solidFill>
                   </a:tcPr>
                 </a:tc>
+                <a:extLst>
+                  <a:ext uri="{0D108BD9-81ED-4DB2-BD59-A6C34878D82A}">
+                    <a16:rowId xmlns:a16="http://schemas.microsoft.com/office/drawing/2014/main" val="10001"/>
+                  </a:ext>
+                </a:extLst>
               </a:tr>
               <a:tr h="304800">
                 <a:tc>
@@ -12897,7 +12870,7 @@
                     <a:bodyPr/>
                     <a:lstStyle/>
                     <a:p>
-                      <a:pPr algn="l" indent="0" marL="0">
+                      <a:pPr marL="0" indent="0" algn="l">
                         <a:buNone/>
                       </a:pPr>
                       <a:r>
@@ -12911,7 +12884,7 @@
                       <a:endParaRPr lang="en-US" sz="1200" dirty="0"/>
                     </a:p>
                   </a:txBody>
-                  <a:tcPr marL="91440" marR="91440" marT="45720" marB="45720" anchor="ctr">
+                  <a:tcPr anchor="ctr">
                     <a:lnL w="12700" cap="flat" cmpd="sng" algn="ctr">
                       <a:solidFill>
                         <a:srgbClr val="E2E8F0"/>
@@ -12958,7 +12931,7 @@
                     <a:bodyPr/>
                     <a:lstStyle/>
                     <a:p>
-                      <a:pPr algn="l" indent="0" marL="0">
+                      <a:pPr marL="0" indent="0" algn="l">
                         <a:buNone/>
                       </a:pPr>
                       <a:r>
@@ -12972,7 +12945,7 @@
                       <a:endParaRPr lang="en-US" sz="1200" dirty="0"/>
                     </a:p>
                   </a:txBody>
-                  <a:tcPr marL="91440" marR="91440" marT="45720" marB="45720" anchor="ctr">
+                  <a:tcPr anchor="ctr">
                     <a:lnL w="12700" cap="flat" cmpd="sng" algn="ctr">
                       <a:solidFill>
                         <a:srgbClr val="E2E8F0"/>
@@ -13019,7 +12992,7 @@
                     <a:bodyPr/>
                     <a:lstStyle/>
                     <a:p>
-                      <a:pPr algn="l" indent="0" marL="0">
+                      <a:pPr marL="0" indent="0" algn="l">
                         <a:buNone/>
                       </a:pPr>
                       <a:r>
@@ -13033,7 +13006,7 @@
                       <a:endParaRPr lang="en-US" sz="1200" dirty="0"/>
                     </a:p>
                   </a:txBody>
-                  <a:tcPr marL="91440" marR="91440" marT="45720" marB="45720" anchor="ctr">
+                  <a:tcPr anchor="ctr">
                     <a:lnL w="12700" cap="flat" cmpd="sng" algn="ctr">
                       <a:solidFill>
                         <a:srgbClr val="E2E8F0"/>
@@ -13075,6 +13048,11 @@
                     </a:solidFill>
                   </a:tcPr>
                 </a:tc>
+                <a:extLst>
+                  <a:ext uri="{0D108BD9-81ED-4DB2-BD59-A6C34878D82A}">
+                    <a16:rowId xmlns:a16="http://schemas.microsoft.com/office/drawing/2014/main" val="10002"/>
+                  </a:ext>
+                </a:extLst>
               </a:tr>
               <a:tr h="304800">
                 <a:tc>
@@ -13082,7 +13060,7 @@
                     <a:bodyPr/>
                     <a:lstStyle/>
                     <a:p>
-                      <a:pPr algn="l" indent="0" marL="0">
+                      <a:pPr marL="0" indent="0" algn="l">
                         <a:buNone/>
                       </a:pPr>
                       <a:r>
@@ -13096,7 +13074,7 @@
                       <a:endParaRPr lang="en-US" sz="1200" dirty="0"/>
                     </a:p>
                   </a:txBody>
-                  <a:tcPr marL="91440" marR="91440" marT="45720" marB="45720" anchor="ctr">
+                  <a:tcPr anchor="ctr">
                     <a:lnL w="12700" cap="flat" cmpd="sng" algn="ctr">
                       <a:solidFill>
                         <a:srgbClr val="E2E8F0"/>
@@ -13143,7 +13121,7 @@
                     <a:bodyPr/>
                     <a:lstStyle/>
                     <a:p>
-                      <a:pPr algn="l" indent="0" marL="0">
+                      <a:pPr marL="0" indent="0" algn="l">
                         <a:buNone/>
                       </a:pPr>
                       <a:r>
@@ -13157,7 +13135,7 @@
                       <a:endParaRPr lang="en-US" sz="1200" dirty="0"/>
                     </a:p>
                   </a:txBody>
-                  <a:tcPr marL="91440" marR="91440" marT="45720" marB="45720" anchor="ctr">
+                  <a:tcPr anchor="ctr">
                     <a:lnL w="12700" cap="flat" cmpd="sng" algn="ctr">
                       <a:solidFill>
                         <a:srgbClr val="E2E8F0"/>
@@ -13204,7 +13182,7 @@
                     <a:bodyPr/>
                     <a:lstStyle/>
                     <a:p>
-                      <a:pPr algn="l" indent="0" marL="0">
+                      <a:pPr marL="0" indent="0" algn="l">
                         <a:buNone/>
                       </a:pPr>
                       <a:r>
@@ -13218,7 +13196,7 @@
                       <a:endParaRPr lang="en-US" sz="1200" dirty="0"/>
                     </a:p>
                   </a:txBody>
-                  <a:tcPr marL="91440" marR="91440" marT="45720" marB="45720" anchor="ctr">
+                  <a:tcPr anchor="ctr">
                     <a:lnL w="12700" cap="flat" cmpd="sng" algn="ctr">
                       <a:solidFill>
                         <a:srgbClr val="E2E8F0"/>
@@ -13260,6 +13238,11 @@
                     </a:solidFill>
                   </a:tcPr>
                 </a:tc>
+                <a:extLst>
+                  <a:ext uri="{0D108BD9-81ED-4DB2-BD59-A6C34878D82A}">
+                    <a16:rowId xmlns:a16="http://schemas.microsoft.com/office/drawing/2014/main" val="10003"/>
+                  </a:ext>
+                </a:extLst>
               </a:tr>
               <a:tr h="304800">
                 <a:tc>
@@ -13267,7 +13250,7 @@
                     <a:bodyPr/>
                     <a:lstStyle/>
                     <a:p>
-                      <a:pPr algn="l" indent="0" marL="0">
+                      <a:pPr marL="0" indent="0" algn="l">
                         <a:buNone/>
                       </a:pPr>
                       <a:r>
@@ -13281,7 +13264,7 @@
                       <a:endParaRPr lang="en-US" sz="1200" dirty="0"/>
                     </a:p>
                   </a:txBody>
-                  <a:tcPr marL="91440" marR="91440" marT="45720" marB="45720" anchor="ctr">
+                  <a:tcPr anchor="ctr">
                     <a:lnL w="12700" cap="flat" cmpd="sng" algn="ctr">
                       <a:solidFill>
                         <a:srgbClr val="E2E8F0"/>
@@ -13328,7 +13311,7 @@
                     <a:bodyPr/>
                     <a:lstStyle/>
                     <a:p>
-                      <a:pPr algn="l" indent="0" marL="0">
+                      <a:pPr marL="0" indent="0" algn="l">
                         <a:buNone/>
                       </a:pPr>
                       <a:r>
@@ -13342,7 +13325,7 @@
                       <a:endParaRPr lang="en-US" sz="1200" dirty="0"/>
                     </a:p>
                   </a:txBody>
-                  <a:tcPr marL="91440" marR="91440" marT="45720" marB="45720" anchor="ctr">
+                  <a:tcPr anchor="ctr">
                     <a:lnL w="12700" cap="flat" cmpd="sng" algn="ctr">
                       <a:solidFill>
                         <a:srgbClr val="E2E8F0"/>
@@ -13389,7 +13372,7 @@
                     <a:bodyPr/>
                     <a:lstStyle/>
                     <a:p>
-                      <a:pPr algn="l" indent="0" marL="0">
+                      <a:pPr marL="0" indent="0" algn="l">
                         <a:buNone/>
                       </a:pPr>
                       <a:r>
@@ -13403,7 +13386,7 @@
                       <a:endParaRPr lang="en-US" sz="1200" dirty="0"/>
                     </a:p>
                   </a:txBody>
-                  <a:tcPr marL="91440" marR="91440" marT="45720" marB="45720" anchor="ctr">
+                  <a:tcPr anchor="ctr">
                     <a:lnL w="12700" cap="flat" cmpd="sng" algn="ctr">
                       <a:solidFill>
                         <a:srgbClr val="E2E8F0"/>
@@ -13445,6 +13428,11 @@
                     </a:solidFill>
                   </a:tcPr>
                 </a:tc>
+                <a:extLst>
+                  <a:ext uri="{0D108BD9-81ED-4DB2-BD59-A6C34878D82A}">
+                    <a16:rowId xmlns:a16="http://schemas.microsoft.com/office/drawing/2014/main" val="10004"/>
+                  </a:ext>
+                </a:extLst>
               </a:tr>
               <a:tr h="304800">
                 <a:tc>
@@ -13452,7 +13440,7 @@
                     <a:bodyPr/>
                     <a:lstStyle/>
                     <a:p>
-                      <a:pPr algn="l" indent="0" marL="0">
+                      <a:pPr marL="0" indent="0" algn="l">
                         <a:buNone/>
                       </a:pPr>
                       <a:r>
@@ -13466,7 +13454,7 @@
                       <a:endParaRPr lang="en-US" sz="1200" dirty="0"/>
                     </a:p>
                   </a:txBody>
-                  <a:tcPr marL="91440" marR="91440" marT="45720" marB="45720" anchor="ctr">
+                  <a:tcPr anchor="ctr">
                     <a:lnL w="12700" cap="flat" cmpd="sng" algn="ctr">
                       <a:solidFill>
                         <a:srgbClr val="E2E8F0"/>
@@ -13513,7 +13501,7 @@
                     <a:bodyPr/>
                     <a:lstStyle/>
                     <a:p>
-                      <a:pPr algn="l" indent="0" marL="0">
+                      <a:pPr marL="0" indent="0" algn="l">
                         <a:buNone/>
                       </a:pPr>
                       <a:r>
@@ -13527,7 +13515,7 @@
                       <a:endParaRPr lang="en-US" sz="1200" dirty="0"/>
                     </a:p>
                   </a:txBody>
-                  <a:tcPr marL="91440" marR="91440" marT="45720" marB="45720" anchor="ctr">
+                  <a:tcPr anchor="ctr">
                     <a:lnL w="12700" cap="flat" cmpd="sng" algn="ctr">
                       <a:solidFill>
                         <a:srgbClr val="E2E8F0"/>
@@ -13574,7 +13562,7 @@
                     <a:bodyPr/>
                     <a:lstStyle/>
                     <a:p>
-                      <a:pPr algn="l" indent="0" marL="0">
+                      <a:pPr marL="0" indent="0" algn="l">
                         <a:buNone/>
                       </a:pPr>
                       <a:r>
@@ -13588,7 +13576,7 @@
                       <a:endParaRPr lang="en-US" sz="1200" dirty="0"/>
                     </a:p>
                   </a:txBody>
-                  <a:tcPr marL="91440" marR="91440" marT="45720" marB="45720" anchor="ctr">
+                  <a:tcPr anchor="ctr">
                     <a:lnL w="12700" cap="flat" cmpd="sng" algn="ctr">
                       <a:solidFill>
                         <a:srgbClr val="E2E8F0"/>
@@ -13630,6 +13618,11 @@
                     </a:solidFill>
                   </a:tcPr>
                 </a:tc>
+                <a:extLst>
+                  <a:ext uri="{0D108BD9-81ED-4DB2-BD59-A6C34878D82A}">
+                    <a16:rowId xmlns:a16="http://schemas.microsoft.com/office/drawing/2014/main" val="10005"/>
+                  </a:ext>
+                </a:extLst>
               </a:tr>
             </a:tbl>
           </a:graphicData>
@@ -13651,6 +13644,7 @@
         <a:solidFill>
           <a:srgbClr val="FFFFFF"/>
         </a:solidFill>
+        <a:effectLst/>
       </p:bgPr>
     </p:bg>
     <p:spTree>
@@ -13688,7 +13682,7 @@
           <a:bodyPr wrap="square" lIns="0" tIns="0" rIns="0" bIns="0" rtlCol="0" anchor="ctr"/>
           <a:lstStyle/>
           <a:p>
-            <a:pPr indent="0" marL="0">
+            <a:pPr marL="0" indent="0">
               <a:buNone/>
             </a:pPr>
             <a:r>
@@ -13747,7 +13741,7 @@
           <a:bodyPr wrap="square" lIns="0" tIns="0" rIns="0" bIns="0" rtlCol="0" anchor="ctr"/>
           <a:lstStyle/>
           <a:p>
-            <a:pPr algn="ctr" indent="0" marL="0">
+            <a:pPr marL="0" indent="0" algn="ctr">
               <a:buNone/>
             </a:pPr>
             <a:r>
@@ -13806,7 +13800,7 @@
           <a:bodyPr wrap="square" lIns="0" tIns="0" rIns="0" bIns="0" rtlCol="0" anchor="ctr"/>
           <a:lstStyle/>
           <a:p>
-            <a:pPr algn="ctr" indent="0" marL="0">
+            <a:pPr marL="0" indent="0" algn="ctr">
               <a:buNone/>
             </a:pPr>
             <a:r>
@@ -13845,7 +13839,7 @@
           <a:bodyPr wrap="square" rtlCol="0" anchor="ctr"/>
           <a:lstStyle/>
           <a:p>
-            <a:pPr algn="l" indent="0" marL="0">
+            <a:pPr marL="0" indent="0" algn="l">
               <a:buNone/>
             </a:pPr>
             <a:r>
@@ -13884,7 +13878,7 @@
           <a:bodyPr wrap="square" rtlCol="0" anchor="ctr"/>
           <a:lstStyle/>
           <a:p>
-            <a:pPr algn="l" indent="0" marL="0">
+            <a:pPr marL="0" indent="0" algn="l">
               <a:buNone/>
             </a:pPr>
             <a:r>
@@ -13923,7 +13917,7 @@
           <a:bodyPr wrap="square" rtlCol="0" anchor="ctr"/>
           <a:lstStyle/>
           <a:p>
-            <a:pPr algn="l" indent="0" marL="0">
+            <a:pPr marL="0" indent="0" algn="l">
               <a:buNone/>
             </a:pPr>
             <a:r>
@@ -13962,7 +13956,7 @@
           <a:bodyPr wrap="square" rtlCol="0" anchor="ctr"/>
           <a:lstStyle/>
           <a:p>
-            <a:pPr algn="l" indent="0" marL="0">
+            <a:pPr marL="0" indent="0" algn="l">
               <a:buNone/>
             </a:pPr>
             <a:r>
@@ -14001,7 +13995,7 @@
           <a:bodyPr wrap="square" rtlCol="0" anchor="ctr"/>
           <a:lstStyle/>
           <a:p>
-            <a:pPr algn="l" indent="0" marL="0">
+            <a:pPr marL="0" indent="0" algn="l">
               <a:buNone/>
             </a:pPr>
             <a:r>
@@ -14040,7 +14034,7 @@
           <a:bodyPr wrap="square" rtlCol="0" anchor="ctr"/>
           <a:lstStyle/>
           <a:p>
-            <a:pPr algn="l" indent="0" marL="0">
+            <a:pPr marL="0" indent="0" algn="l">
               <a:buNone/>
             </a:pPr>
             <a:r>
@@ -14079,7 +14073,7 @@
           <a:bodyPr wrap="square" rtlCol="0" anchor="ctr"/>
           <a:lstStyle/>
           <a:p>
-            <a:pPr algn="l" indent="0" marL="0">
+            <a:pPr marL="0" indent="0" algn="l">
               <a:buNone/>
             </a:pPr>
             <a:r>
@@ -14118,7 +14112,7 @@
           <a:bodyPr wrap="square" rtlCol="0" anchor="ctr"/>
           <a:lstStyle/>
           <a:p>
-            <a:pPr algn="l" indent="0" marL="0">
+            <a:pPr marL="0" indent="0" algn="l">
               <a:buNone/>
             </a:pPr>
             <a:r>
@@ -14157,7 +14151,7 @@
           <a:bodyPr wrap="square" rtlCol="0" anchor="ctr"/>
           <a:lstStyle/>
           <a:p>
-            <a:pPr algn="l" indent="0" marL="0">
+            <a:pPr marL="0" indent="0" algn="l">
               <a:buNone/>
             </a:pPr>
             <a:r>
@@ -14196,7 +14190,7 @@
           <a:bodyPr wrap="square" rtlCol="0" anchor="ctr"/>
           <a:lstStyle/>
           <a:p>
-            <a:pPr algn="l" indent="0" marL="0">
+            <a:pPr marL="0" indent="0" algn="l">
               <a:buNone/>
             </a:pPr>
             <a:r>
@@ -14235,7 +14229,7 @@
           <a:bodyPr wrap="square" rtlCol="0" anchor="ctr"/>
           <a:lstStyle/>
           <a:p>
-            <a:pPr algn="l" indent="0" marL="0">
+            <a:pPr marL="0" indent="0" algn="l">
               <a:buNone/>
             </a:pPr>
             <a:r>
@@ -14274,9 +14268,6 @@
           <a:bodyPr wrap="square" rtlCol="0" anchor="ctr"/>
           <a:lstStyle/>
           <a:p>
-            <a:pPr algn="l" indent="0" marL="0">
-              <a:buNone/>
-            </a:pPr>
             <a:r>
               <a:rPr lang="en-US" sz="1200" dirty="0">
                 <a:solidFill>
@@ -14286,9 +14277,24 @@
                 <a:ea typeface="Arial" pitchFamily="34" charset="-122"/>
                 <a:cs typeface="Arial" pitchFamily="34" charset="-120"/>
               </a:rPr>
-              <a:t>✗ Permissions</a:t>
+              <a:t>✗ </a:t>
             </a:r>
-            <a:endParaRPr lang="en-US" sz="1200" dirty="0"/>
+            <a:r>
+              <a:rPr lang="en-US" sz="1200" dirty="0" err="1">
+                <a:solidFill>
+                  <a:srgbClr val="FF0000"/>
+                </a:solidFill>
+                <a:latin typeface="Arial" pitchFamily="34" charset="0"/>
+                <a:ea typeface="Arial" pitchFamily="34" charset="-122"/>
+                <a:cs typeface="Arial" pitchFamily="34" charset="-120"/>
+              </a:rPr>
+              <a:t>Assiduité</a:t>
+            </a:r>
+            <a:endParaRPr lang="en-US" sz="1200" dirty="0">
+              <a:solidFill>
+                <a:srgbClr val="FF0000"/>
+              </a:solidFill>
+            </a:endParaRPr>
           </a:p>
         </p:txBody>
       </p:sp>
@@ -14313,7 +14319,7 @@
           <a:bodyPr wrap="square" rtlCol="0" anchor="ctr"/>
           <a:lstStyle/>
           <a:p>
-            <a:pPr algn="l" indent="0" marL="0">
+            <a:pPr marL="0" indent="0" algn="l">
               <a:buNone/>
             </a:pPr>
             <a:r>
@@ -14352,9 +14358,6 @@
           <a:bodyPr wrap="square" rtlCol="0" anchor="ctr"/>
           <a:lstStyle/>
           <a:p>
-            <a:pPr algn="l" indent="0" marL="0">
-              <a:buNone/>
-            </a:pPr>
             <a:r>
               <a:rPr lang="en-US" sz="1200" dirty="0">
                 <a:solidFill>
@@ -14364,7 +14367,18 @@
                 <a:ea typeface="Arial" pitchFamily="34" charset="-122"/>
                 <a:cs typeface="Arial" pitchFamily="34" charset="-120"/>
               </a:rPr>
-              <a:t>◐ Financier</a:t>
+              <a:t>◐ </a:t>
+            </a:r>
+            <a:r>
+              <a:rPr lang="en-US" sz="1200" dirty="0" err="1">
+                <a:solidFill>
+                  <a:srgbClr val="D97706"/>
+                </a:solidFill>
+                <a:latin typeface="Arial" pitchFamily="34" charset="0"/>
+                <a:ea typeface="Arial" pitchFamily="34" charset="-122"/>
+                <a:cs typeface="Arial" pitchFamily="34" charset="-120"/>
+              </a:rPr>
+              <a:t>Périodes</a:t>
             </a:r>
             <a:endParaRPr lang="en-US" sz="1200" dirty="0"/>
           </a:p>
@@ -14671,4 +14685,319 @@
     </a:ext>
   </a:extLst>
 </a:theme>
+</file>
+
+<file path=ppt/theme/theme2.xml><?xml version="1.0" encoding="utf-8"?>
+<a:theme xmlns:a="http://schemas.openxmlformats.org/drawingml/2006/main" name="Thème Office">
+  <a:themeElements>
+    <a:clrScheme name="Office">
+      <a:dk1>
+        <a:sysClr val="windowText" lastClr="000000"/>
+      </a:dk1>
+      <a:lt1>
+        <a:sysClr val="window" lastClr="FFFFFF"/>
+      </a:lt1>
+      <a:dk2>
+        <a:srgbClr val="0E2841"/>
+      </a:dk2>
+      <a:lt2>
+        <a:srgbClr val="E8E8E8"/>
+      </a:lt2>
+      <a:accent1>
+        <a:srgbClr val="156082"/>
+      </a:accent1>
+      <a:accent2>
+        <a:srgbClr val="E97132"/>
+      </a:accent2>
+      <a:accent3>
+        <a:srgbClr val="196B24"/>
+      </a:accent3>
+      <a:accent4>
+        <a:srgbClr val="0F9ED5"/>
+      </a:accent4>
+      <a:accent5>
+        <a:srgbClr val="A02B93"/>
+      </a:accent5>
+      <a:accent6>
+        <a:srgbClr val="4EA72E"/>
+      </a:accent6>
+      <a:hlink>
+        <a:srgbClr val="467886"/>
+      </a:hlink>
+      <a:folHlink>
+        <a:srgbClr val="96607D"/>
+      </a:folHlink>
+    </a:clrScheme>
+    <a:fontScheme name="Office">
+      <a:majorFont>
+        <a:latin typeface="Aptos Display" panose="02110004020202020204"/>
+        <a:ea typeface=""/>
+        <a:cs typeface=""/>
+        <a:font script="Jpan" typeface="游ゴシック Light"/>
+        <a:font script="Hang" typeface="맑은 고딕"/>
+        <a:font script="Hans" typeface="等线 Light"/>
+        <a:font script="Hant" typeface="新細明體"/>
+        <a:font script="Arab" typeface="Times New Roman"/>
+        <a:font script="Hebr" typeface="Times New Roman"/>
+        <a:font script="Thai" typeface="Angsana New"/>
+        <a:font script="Ethi" typeface="Nyala"/>
+        <a:font script="Beng" typeface="Vrinda"/>
+        <a:font script="Gujr" typeface="Shruti"/>
+        <a:font script="Khmr" typeface="MoolBoran"/>
+        <a:font script="Knda" typeface="Tunga"/>
+        <a:font script="Guru" typeface="Raavi"/>
+        <a:font script="Cans" typeface="Euphemia"/>
+        <a:font script="Cher" typeface="Plantagenet Cherokee"/>
+        <a:font script="Yiii" typeface="Microsoft Yi Baiti"/>
+        <a:font script="Tibt" typeface="Microsoft Himalaya"/>
+        <a:font script="Thaa" typeface="MV Boli"/>
+        <a:font script="Deva" typeface="Mangal"/>
+        <a:font script="Telu" typeface="Gautami"/>
+        <a:font script="Taml" typeface="Latha"/>
+        <a:font script="Syrc" typeface="Estrangelo Edessa"/>
+        <a:font script="Orya" typeface="Kalinga"/>
+        <a:font script="Mlym" typeface="Kartika"/>
+        <a:font script="Laoo" typeface="DokChampa"/>
+        <a:font script="Sinh" typeface="Iskoola Pota"/>
+        <a:font script="Mong" typeface="Mongolian Baiti"/>
+        <a:font script="Viet" typeface="Times New Roman"/>
+        <a:font script="Uigh" typeface="Microsoft Uighur"/>
+        <a:font script="Geor" typeface="Sylfaen"/>
+        <a:font script="Armn" typeface="Arial"/>
+        <a:font script="Bugi" typeface="Leelawadee UI"/>
+        <a:font script="Bopo" typeface="Microsoft JhengHei"/>
+        <a:font script="Java" typeface="Javanese Text"/>
+        <a:font script="Lisu" typeface="Segoe UI"/>
+        <a:font script="Mymr" typeface="Myanmar Text"/>
+        <a:font script="Nkoo" typeface="Ebrima"/>
+        <a:font script="Olck" typeface="Nirmala UI"/>
+        <a:font script="Osma" typeface="Ebrima"/>
+        <a:font script="Phag" typeface="Phagspa"/>
+        <a:font script="Syrn" typeface="Estrangelo Edessa"/>
+        <a:font script="Syrj" typeface="Estrangelo Edessa"/>
+        <a:font script="Syre" typeface="Estrangelo Edessa"/>
+        <a:font script="Sora" typeface="Nirmala UI"/>
+        <a:font script="Tale" typeface="Microsoft Tai Le"/>
+        <a:font script="Talu" typeface="Microsoft New Tai Lue"/>
+        <a:font script="Tfng" typeface="Ebrima"/>
+      </a:majorFont>
+      <a:minorFont>
+        <a:latin typeface="Aptos" panose="02110004020202020204"/>
+        <a:ea typeface=""/>
+        <a:cs typeface=""/>
+        <a:font script="Jpan" typeface="游ゴシック"/>
+        <a:font script="Hang" typeface="맑은 고딕"/>
+        <a:font script="Hans" typeface="等线"/>
+        <a:font script="Hant" typeface="新細明體"/>
+        <a:font script="Arab" typeface="Arial"/>
+        <a:font script="Hebr" typeface="Arial"/>
+        <a:font script="Thai" typeface="Cordia New"/>
+        <a:font script="Ethi" typeface="Nyala"/>
+        <a:font script="Beng" typeface="Vrinda"/>
+        <a:font script="Gujr" typeface="Shruti"/>
+        <a:font script="Khmr" typeface="DaunPenh"/>
+        <a:font script="Knda" typeface="Tunga"/>
+        <a:font script="Guru" typeface="Raavi"/>
+        <a:font script="Cans" typeface="Euphemia"/>
+        <a:font script="Cher" typeface="Plantagenet Cherokee"/>
+        <a:font script="Yiii" typeface="Microsoft Yi Baiti"/>
+        <a:font script="Tibt" typeface="Microsoft Himalaya"/>
+        <a:font script="Thaa" typeface="MV Boli"/>
+        <a:font script="Deva" typeface="Mangal"/>
+        <a:font script="Telu" typeface="Gautami"/>
+        <a:font script="Taml" typeface="Latha"/>
+        <a:font script="Syrc" typeface="Estrangelo Edessa"/>
+        <a:font script="Orya" typeface="Kalinga"/>
+        <a:font script="Mlym" typeface="Kartika"/>
+        <a:font script="Laoo" typeface="DokChampa"/>
+        <a:font script="Sinh" typeface="Iskoola Pota"/>
+        <a:font script="Mong" typeface="Mongolian Baiti"/>
+        <a:font script="Viet" typeface="Arial"/>
+        <a:font script="Uigh" typeface="Microsoft Uighur"/>
+        <a:font script="Geor" typeface="Sylfaen"/>
+        <a:font script="Armn" typeface="Arial"/>
+        <a:font script="Bugi" typeface="Leelawadee UI"/>
+        <a:font script="Bopo" typeface="Microsoft JhengHei"/>
+        <a:font script="Java" typeface="Javanese Text"/>
+        <a:font script="Lisu" typeface="Segoe UI"/>
+        <a:font script="Mymr" typeface="Myanmar Text"/>
+        <a:font script="Nkoo" typeface="Ebrima"/>
+        <a:font script="Olck" typeface="Nirmala UI"/>
+        <a:font script="Osma" typeface="Ebrima"/>
+        <a:font script="Phag" typeface="Phagspa"/>
+        <a:font script="Syrn" typeface="Estrangelo Edessa"/>
+        <a:font script="Syrj" typeface="Estrangelo Edessa"/>
+        <a:font script="Syre" typeface="Estrangelo Edessa"/>
+        <a:font script="Sora" typeface="Nirmala UI"/>
+        <a:font script="Tale" typeface="Microsoft Tai Le"/>
+        <a:font script="Talu" typeface="Microsoft New Tai Lue"/>
+        <a:font script="Tfng" typeface="Ebrima"/>
+      </a:minorFont>
+    </a:fontScheme>
+    <a:fmtScheme name="Office">
+      <a:fillStyleLst>
+        <a:solidFill>
+          <a:schemeClr val="phClr"/>
+        </a:solidFill>
+        <a:gradFill rotWithShape="1">
+          <a:gsLst>
+            <a:gs pos="0">
+              <a:schemeClr val="phClr">
+                <a:lumMod val="110000"/>
+                <a:satMod val="105000"/>
+                <a:tint val="67000"/>
+              </a:schemeClr>
+            </a:gs>
+            <a:gs pos="50000">
+              <a:schemeClr val="phClr">
+                <a:lumMod val="105000"/>
+                <a:satMod val="103000"/>
+                <a:tint val="73000"/>
+              </a:schemeClr>
+            </a:gs>
+            <a:gs pos="100000">
+              <a:schemeClr val="phClr">
+                <a:lumMod val="105000"/>
+                <a:satMod val="109000"/>
+                <a:tint val="81000"/>
+              </a:schemeClr>
+            </a:gs>
+          </a:gsLst>
+          <a:lin ang="5400000" scaled="0"/>
+        </a:gradFill>
+        <a:gradFill rotWithShape="1">
+          <a:gsLst>
+            <a:gs pos="0">
+              <a:schemeClr val="phClr">
+                <a:satMod val="103000"/>
+                <a:lumMod val="102000"/>
+                <a:tint val="94000"/>
+              </a:schemeClr>
+            </a:gs>
+            <a:gs pos="50000">
+              <a:schemeClr val="phClr">
+                <a:satMod val="110000"/>
+                <a:lumMod val="100000"/>
+                <a:shade val="100000"/>
+              </a:schemeClr>
+            </a:gs>
+            <a:gs pos="100000">
+              <a:schemeClr val="phClr">
+                <a:lumMod val="99000"/>
+                <a:satMod val="120000"/>
+                <a:shade val="78000"/>
+              </a:schemeClr>
+            </a:gs>
+          </a:gsLst>
+          <a:lin ang="5400000" scaled="0"/>
+        </a:gradFill>
+      </a:fillStyleLst>
+      <a:lnStyleLst>
+        <a:ln w="12700" cap="flat" cmpd="sng" algn="ctr">
+          <a:solidFill>
+            <a:schemeClr val="phClr"/>
+          </a:solidFill>
+          <a:prstDash val="solid"/>
+          <a:miter lim="800000"/>
+        </a:ln>
+        <a:ln w="19050" cap="flat" cmpd="sng" algn="ctr">
+          <a:solidFill>
+            <a:schemeClr val="phClr"/>
+          </a:solidFill>
+          <a:prstDash val="solid"/>
+          <a:miter lim="800000"/>
+        </a:ln>
+        <a:ln w="25400" cap="flat" cmpd="sng" algn="ctr">
+          <a:solidFill>
+            <a:schemeClr val="phClr"/>
+          </a:solidFill>
+          <a:prstDash val="solid"/>
+          <a:miter lim="800000"/>
+        </a:ln>
+      </a:lnStyleLst>
+      <a:effectStyleLst>
+        <a:effectStyle>
+          <a:effectLst/>
+        </a:effectStyle>
+        <a:effectStyle>
+          <a:effectLst/>
+        </a:effectStyle>
+        <a:effectStyle>
+          <a:effectLst>
+            <a:outerShdw blurRad="57150" dist="19050" dir="5400000" algn="ctr" rotWithShape="0">
+              <a:srgbClr val="000000">
+                <a:alpha val="63000"/>
+              </a:srgbClr>
+            </a:outerShdw>
+          </a:effectLst>
+        </a:effectStyle>
+      </a:effectStyleLst>
+      <a:bgFillStyleLst>
+        <a:solidFill>
+          <a:schemeClr val="phClr"/>
+        </a:solidFill>
+        <a:solidFill>
+          <a:schemeClr val="phClr">
+            <a:tint val="95000"/>
+            <a:satMod val="170000"/>
+          </a:schemeClr>
+        </a:solidFill>
+        <a:gradFill rotWithShape="1">
+          <a:gsLst>
+            <a:gs pos="0">
+              <a:schemeClr val="phClr">
+                <a:tint val="93000"/>
+                <a:satMod val="150000"/>
+                <a:shade val="98000"/>
+                <a:lumMod val="102000"/>
+              </a:schemeClr>
+            </a:gs>
+            <a:gs pos="50000">
+              <a:schemeClr val="phClr">
+                <a:tint val="98000"/>
+                <a:satMod val="130000"/>
+                <a:shade val="90000"/>
+                <a:lumMod val="103000"/>
+              </a:schemeClr>
+            </a:gs>
+            <a:gs pos="100000">
+              <a:schemeClr val="phClr">
+                <a:shade val="63000"/>
+                <a:satMod val="120000"/>
+              </a:schemeClr>
+            </a:gs>
+          </a:gsLst>
+          <a:lin ang="5400000" scaled="0"/>
+        </a:gradFill>
+      </a:bgFillStyleLst>
+    </a:fmtScheme>
+  </a:themeElements>
+  <a:objectDefaults>
+    <a:lnDef>
+      <a:spPr/>
+      <a:bodyPr/>
+      <a:lstStyle/>
+      <a:style>
+        <a:lnRef idx="2">
+          <a:schemeClr val="accent1"/>
+        </a:lnRef>
+        <a:fillRef idx="0">
+          <a:schemeClr val="accent1"/>
+        </a:fillRef>
+        <a:effectRef idx="1">
+          <a:schemeClr val="accent1"/>
+        </a:effectRef>
+        <a:fontRef idx="minor">
+          <a:schemeClr val="tx1"/>
+        </a:fontRef>
+      </a:style>
+    </a:lnDef>
+  </a:objectDefaults>
+  <a:extraClrSchemeLst/>
+  <a:extLst>
+    <a:ext uri="{05A4C25C-085E-4340-85A3-A5531E510DB2}">
+      <thm15:themeFamily xmlns:thm15="http://schemas.microsoft.com/office/thememl/2012/main" name="Office Theme" id="{2E142A2C-CD16-42D6-873A-C26D2A0506FA}" vid="{1BDDFF52-6CD6-40A5-AB3C-68EB2F1E4D0A}"/>
+    </a:ext>
+  </a:extLst>
+</a:theme>
 </file>
</xml_diff>

<commit_message>
📊 update data 2026-03-31 13:35
</commit_message>
<xml_diff>
--- a/audit_approfondi_presentation.pptx
+++ b/audit_approfondi_presentation.pptx
@@ -5160,7 +5160,7 @@
           <p:nvPr>
             <p:extLst>
               <p:ext uri="{D42A27DB-BD31-4B8C-83A1-F6EECF244321}">
-                <p14:modId xmlns:p14="http://schemas.microsoft.com/office/powerpoint/2010/main" val="1579011935"/>
+                <p14:modId xmlns:p14="http://schemas.microsoft.com/office/powerpoint/2010/main" val="2665520180"/>
               </p:ext>
             </p:extLst>
           </p:nvPr>
@@ -6152,18 +6152,51 @@
                     <a:bodyPr/>
                     <a:lstStyle/>
                     <a:p>
-                      <a:pPr marL="0" indent="0" algn="l">
+                      <a:pPr marL="0" marR="0" lvl="0" indent="0" algn="l" defTabSz="914400" rtl="0" eaLnBrk="1" fontAlgn="auto" latinLnBrk="0" hangingPunct="1">
+                        <a:lnSpc>
+                          <a:spcPct val="100000"/>
+                        </a:lnSpc>
+                        <a:spcBef>
+                          <a:spcPts val="0"/>
+                        </a:spcBef>
+                        <a:spcAft>
+                          <a:spcPts val="0"/>
+                        </a:spcAft>
+                        <a:buClrTx/>
+                        <a:buSzTx/>
+                        <a:buFontTx/>
                         <a:buNone/>
+                        <a:tabLst/>
+                        <a:defRPr/>
                       </a:pPr>
+                      <a:r>
+                        <a:rPr lang="en-US" sz="1600" dirty="0" err="1">
+                          <a:solidFill>
+                            <a:srgbClr val="1E293B"/>
+                          </a:solidFill>
+                        </a:rPr>
+                        <a:t>Périodes</a:t>
+                      </a:r>
                       <a:r>
                         <a:rPr lang="en-US" sz="1600" dirty="0">
                           <a:solidFill>
                             <a:srgbClr val="1E293B"/>
                           </a:solidFill>
                         </a:rPr>
-                        <a:t>Périodes</a:t>
+                        <a:t> </a:t>
                       </a:r>
-                      <a:endParaRPr lang="en-US" sz="1600" dirty="0"/>
+                      <a:r>
+                        <a:rPr lang="fr-SN" sz="1800" kern="1200" dirty="0">
+                          <a:solidFill>
+                            <a:schemeClr val="tx1"/>
+                          </a:solidFill>
+                          <a:effectLst/>
+                          <a:latin typeface="+mn-lt"/>
+                          <a:ea typeface="+mn-ea"/>
+                          <a:cs typeface="+mn-cs"/>
+                        </a:rPr>
+                        <a:t>(couverture)</a:t>
+                      </a:r>
                     </a:p>
                   </a:txBody>
                   <a:tcPr anchor="ctr">
@@ -6342,18 +6375,51 @@
                     <a:bodyPr/>
                     <a:lstStyle/>
                     <a:p>
-                      <a:pPr marL="0" indent="0" algn="l">
+                      <a:pPr marL="0" marR="0" lvl="0" indent="0" algn="l" defTabSz="914400" rtl="0" eaLnBrk="1" fontAlgn="auto" latinLnBrk="0" hangingPunct="1">
+                        <a:lnSpc>
+                          <a:spcPct val="100000"/>
+                        </a:lnSpc>
+                        <a:spcBef>
+                          <a:spcPts val="0"/>
+                        </a:spcBef>
+                        <a:spcAft>
+                          <a:spcPts val="0"/>
+                        </a:spcAft>
+                        <a:buClrTx/>
+                        <a:buSzTx/>
+                        <a:buFontTx/>
                         <a:buNone/>
+                        <a:tabLst/>
+                        <a:defRPr/>
                       </a:pPr>
+                      <a:r>
+                        <a:rPr lang="en-US" sz="1600" dirty="0" err="1">
+                          <a:solidFill>
+                            <a:srgbClr val="1E293B"/>
+                          </a:solidFill>
+                        </a:rPr>
+                        <a:t>Assiduité</a:t>
+                      </a:r>
                       <a:r>
                         <a:rPr lang="en-US" sz="1600" dirty="0">
                           <a:solidFill>
                             <a:srgbClr val="1E293B"/>
                           </a:solidFill>
                         </a:rPr>
-                        <a:t>Assiduité</a:t>
+                        <a:t> </a:t>
                       </a:r>
-                      <a:endParaRPr lang="en-US" sz="1600" dirty="0"/>
+                      <a:r>
+                        <a:rPr lang="fr-SN" sz="1800" kern="1200" dirty="0">
+                          <a:solidFill>
+                            <a:schemeClr val="tx1"/>
+                          </a:solidFill>
+                          <a:effectLst/>
+                          <a:latin typeface="+mn-lt"/>
+                          <a:ea typeface="+mn-ea"/>
+                          <a:cs typeface="+mn-cs"/>
+                        </a:rPr>
+                        <a:t>(couverture)</a:t>
+                      </a:r>
                     </a:p>
                   </a:txBody>
                   <a:tcPr anchor="ctr">

</xml_diff>